<commit_message>
Add live app screenshots to report and deck (closes edit 2.6)
</commit_message>
<xml_diff>
--- a/report/NLP BBC Project .pptx
+++ b/report/NLP BBC Project .pptx
@@ -16,6 +16,7 @@
     <p:sldId id="261" r:id="rId7"/>
     <p:sldId id="262" r:id="rId8"/>
     <p:sldId id="263" r:id="rId9"/>
+    <p:sldId id="271" r:id="rId30"/>
     <p:sldId id="264" r:id="rId10"/>
     <p:sldId id="265" r:id="rId11"/>
     <p:sldId id="266" r:id="rId12"/>
@@ -1131,11 +1132,79 @@
                 <a:spcPts val="0"/>
               </a:spcBef>
               <a:spcAft>
-                <a:spcPts val="0"/>
+                <a:spcPts val="800"/>
               </a:spcAft>
               <a:buNone/>
             </a:pPr>
-            <a:endParaRPr/>
+            <a:r>
+              <a:rPr lang="en-GB" sz="1200" dirty="0"/>
+              <a:t>ROUGE-L scores the longest common subsequence against a reference answer — it rewards wording overlap.</a:t>
+            </a:r>
+            <a:endParaRPr sz="1200"/>
+          </a:p>
+          <a:p>
+            <a:pPr marL="0" lvl="0" indent="0" algn="l" rtl="0">
+              <a:spcBef>
+                <a:spcPts val="0"/>
+              </a:spcBef>
+              <a:spcAft>
+                <a:spcPts val="800"/>
+              </a:spcAft>
+              <a:buNone/>
+            </a:pPr>
+            <a:r>
+              <a:rPr lang="en-GB" sz="1200" dirty="0"/>
+              <a:t>Metric failure: our reference for 'What sport does Tiger Woods play?' was the full sentence 'Tiger Woods is a professional golfer.' An instruction-tuned model asked a direct question answers tersely — it says 'golf'. That answer is completely correct, and it scores exactly zero, because 'golf' and 'golfer' are different tokens with no common subsequence.</a:t>
+            </a:r>
+            <a:endParaRPr sz="1200"/>
+          </a:p>
+          <a:p>
+            <a:pPr marL="0" lvl="0" indent="0" algn="l" rtl="0">
+              <a:spcBef>
+                <a:spcPts val="0"/>
+              </a:spcBef>
+              <a:spcAft>
+                <a:spcPts val="800"/>
+              </a:spcAft>
+              <a:buNone/>
+            </a:pPr>
+            <a:r>
+              <a:rPr lang="en-GB" sz="1200" dirty="0"/>
+              <a:t>System failure: our other zero is 'Who won the Formula One championship?' → 'ivanovic', which is simply wrong. Four of ten answers are factually wrong — a real limitation of a small generator. Flan-T5-base is small, so its answers are terse, and some of our own questions aren't answerable from this corpus.</a:t>
+            </a:r>
+            <a:endParaRPr sz="1200"/>
+          </a:p>
+          <a:p>
+            <a:pPr marL="0" lvl="0" indent="0" algn="l" rtl="0">
+              <a:spcBef>
+                <a:spcPts val="0"/>
+              </a:spcBef>
+              <a:spcAft>
+                <a:spcPts val="800"/>
+              </a:spcAft>
+              <a:buNone/>
+            </a:pPr>
+            <a:r>
+              <a:rPr lang="en-GB" sz="1200" dirty="0"/>
+              <a:t>What we should have done is measure retrieval and generation separately — Recall@k for the retriever, and score answers with something like BERTScore that credits correct paraphrases.</a:t>
+            </a:r>
+            <a:endParaRPr sz="1200"/>
+          </a:p>
+          <a:p>
+            <a:pPr marL="0" lvl="0" indent="0" algn="l" rtl="0">
+              <a:spcBef>
+                <a:spcPts val="0"/>
+              </a:spcBef>
+              <a:spcAft>
+                <a:spcPts val="800"/>
+              </a:spcAft>
+              <a:buNone/>
+            </a:pPr>
+            <a:r>
+              <a:rPr lang="en-GB" sz="1200" dirty="0"/>
+              <a:t>Retrieval itself is sound: when we query 'Who won the football championship?', it returns two relevant football articles — and a review of the video game Championship Manager, tagged tech. That third hit isn't a bug; it's evidence the retriever is matching on meaning rather than keywords, because it understood 'championship' in a sense our query never disambiguated.</a:t>
+            </a:r>
+            <a:endParaRPr sz="1200"/>
           </a:p>
         </p:txBody>
       </p:sp>
@@ -1339,11 +1408,47 @@
                 <a:spcPts val="0"/>
               </a:spcBef>
               <a:spcAft>
-                <a:spcPts val="0"/>
+                <a:spcPts val="800"/>
               </a:spcAft>
               <a:buNone/>
             </a:pPr>
-            <a:endParaRPr/>
+            <a:r>
+              <a:rPr lang="en-GB" sz="1200" dirty="0"/>
+              <a:t>We built a complete pipeline from raw text to a deployed, working chatbot: unsupervised topic discovery, three classical classifiers, two deep learning approaches, an explainability layer, and a retrieval-based question-answering system.</a:t>
+            </a:r>
+            <a:endParaRPr sz="1200"/>
+          </a:p>
+          <a:p>
+            <a:pPr marL="0" lvl="0" indent="0" algn="l" rtl="0">
+              <a:spcBef>
+                <a:spcPts val="0"/>
+              </a:spcBef>
+              <a:spcAft>
+                <a:spcPts val="800"/>
+              </a:spcAft>
+              <a:buNone/>
+            </a:pPr>
+            <a:r>
+              <a:rPr lang="en-GB" sz="1200" dirty="0"/>
+              <a:t>Pre-training, not depth, is what separates these models — and the best model on the leaderboard isn't always the right model to ship.</a:t>
+            </a:r>
+            <a:endParaRPr sz="1200"/>
+          </a:p>
+          <a:p>
+            <a:pPr marL="0" lvl="0" indent="0" algn="l" rtl="0">
+              <a:spcBef>
+                <a:spcPts val="0"/>
+              </a:spcBef>
+              <a:spcAft>
+                <a:spcPts val="800"/>
+              </a:spcAft>
+              <a:buNone/>
+            </a:pPr>
+            <a:r>
+              <a:rPr lang="en-GB" sz="1200" dirty="0"/>
+              <a:t>Future work: the cleanest next experiment is to initialise that same LSTM from pretrained GloVe or FastText embeddings. We'd also rebuild the RAG evaluation to measure retrieval and generation separately, and test our 'no headroom' explanation on a harder corpus — something like sarcasm or fine-grained sentiment.</a:t>
+            </a:r>
+            <a:endParaRPr sz="1200"/>
           </a:p>
         </p:txBody>
       </p:sp>
@@ -1651,11 +1756,63 @@
                 <a:spcPts val="0"/>
               </a:spcBef>
               <a:spcAft>
-                <a:spcPts val="0"/>
+                <a:spcPts val="800"/>
               </a:spcAft>
               <a:buNone/>
             </a:pPr>
-            <a:endParaRPr/>
+            <a:r>
+              <a:rPr lang="en-GB" sz="1200" dirty="0"/>
+              <a:t>Cleaning: we checked for missing values (none) and removed 99 duplicate or near-duplicate articles, leaving 2,126.</a:t>
+            </a:r>
+            <a:endParaRPr sz="1200"/>
+          </a:p>
+          <a:p>
+            <a:pPr marL="0" lvl="0" indent="0" algn="l" rtl="0">
+              <a:spcBef>
+                <a:spcPts val="0"/>
+              </a:spcBef>
+              <a:spcAft>
+                <a:spcPts val="800"/>
+              </a:spcAft>
+              <a:buNone/>
+            </a:pPr>
+            <a:r>
+              <a:rPr lang="en-GB" sz="1200" dirty="0"/>
+              <a:t>Pipeline: lowercase, strip URLs and HTML tags, expand contractions, remove punctuation, remove stopwords, lemmatise.</a:t>
+            </a:r>
+            <a:endParaRPr sz="1200"/>
+          </a:p>
+          <a:p>
+            <a:pPr marL="0" lvl="0" indent="0" algn="l" rtl="0">
+              <a:spcBef>
+                <a:spcPts val="0"/>
+              </a:spcBef>
+              <a:spcAft>
+                <a:spcPts val="800"/>
+              </a:spcAft>
+              <a:buNone/>
+            </a:pPr>
+            <a:r>
+              <a:rPr lang="en-GB" sz="1200" dirty="0"/>
+              <a:t>We chose lemmatisation over stemming deliberately: stemming can mangle words into non-words, which hurts readability of everything downstream, especially our topic model's keyword lists and our word-embedding neighbours.</a:t>
+            </a:r>
+            <a:endParaRPr sz="1200"/>
+          </a:p>
+          <a:p>
+            <a:pPr marL="0" lvl="0" indent="0" algn="l" rtl="0">
+              <a:spcBef>
+                <a:spcPts val="0"/>
+              </a:spcBef>
+              <a:spcAft>
+                <a:spcPts val="800"/>
+              </a:spcAft>
+              <a:buNone/>
+            </a:pPr>
+            <a:r>
+              <a:rPr lang="en-GB" sz="1200" dirty="0"/>
+              <a:t>We kept two versions of the text throughout the whole project: the original raw text and this cleaned version. Our from-scratch models want the cleaned version, but our pretrained transformer, DistilBERT, performs better on the original uncleaned text, because it has its own subword tokenizer that already knows how to handle punctuation and capitalisation.</a:t>
+            </a:r>
+            <a:endParaRPr sz="1200"/>
           </a:p>
         </p:txBody>
       </p:sp>
@@ -2275,11 +2432,63 @@
                 <a:spcPts val="0"/>
               </a:spcBef>
               <a:spcAft>
-                <a:spcPts val="0"/>
+                <a:spcPts val="800"/>
               </a:spcAft>
               <a:buNone/>
             </a:pPr>
-            <a:endParaRPr/>
+            <a:r>
+              <a:rPr lang="en-GB" sz="1200" dirty="0"/>
+              <a:t>Our two deep learning models are at opposite ends: DistilBERT at 97.2%, the LSTM at 81.6% — while DistilBERT and a bag-of-words SVM differ by 0.2.</a:t>
+            </a:r>
+            <a:endParaRPr sz="1200"/>
+          </a:p>
+          <a:p>
+            <a:pPr marL="0" lvl="0" indent="0" algn="l" rtl="0">
+              <a:spcBef>
+                <a:spcPts val="0"/>
+              </a:spcBef>
+              <a:spcAft>
+                <a:spcPts val="800"/>
+              </a:spcAft>
+              <a:buNone/>
+            </a:pPr>
+            <a:r>
+              <a:rPr lang="en-GB" sz="1200" dirty="0"/>
+              <a:t>DistilBERT starts from representations learned on billions of words and only has to learn the mapping onto five labels. The LSTM starts from random noise and has to learn what words mean and how to classify at the same time.</a:t>
+            </a:r>
+            <a:endParaRPr sz="1200"/>
+          </a:p>
+          <a:p>
+            <a:pPr marL="0" lvl="0" indent="0" algn="l" rtl="0">
+              <a:spcBef>
+                <a:spcPts val="0"/>
+              </a:spcBef>
+              <a:spcAft>
+                <a:spcPts val="800"/>
+              </a:spcAft>
+              <a:buNone/>
+            </a:pPr>
+            <a:r>
+              <a:rPr lang="en-GB" sz="1200" dirty="0"/>
+              <a:t>The transformer's advantage is understanding context and word sense — but BBC categories are so lexically distinct that the word 'shares' or the word 'scored' basically settles the answer on its own.</a:t>
+            </a:r>
+            <a:endParaRPr sz="1200"/>
+          </a:p>
+          <a:p>
+            <a:pPr marL="0" lvl="0" indent="0" algn="l" rtl="0">
+              <a:spcBef>
+                <a:spcPts val="0"/>
+              </a:spcBef>
+              <a:spcAft>
+                <a:spcPts val="800"/>
+              </a:spcAft>
+              <a:buNone/>
+            </a:pPr>
+            <a:r>
+              <a:rPr lang="en-GB" sz="1200" dirty="0"/>
+              <a:t>The margin matters: DistilBERT beats our Linear SVM by 0.21 percentage points. On a test set of 932 articles, that's a difference of two articles. The honest reading is that a 67-million-parameter transformer and a linear model over word counts are tied.</a:t>
+            </a:r>
+            <a:endParaRPr sz="1200"/>
           </a:p>
         </p:txBody>
       </p:sp>
@@ -10488,6 +10697,441 @@
   <p:cSld>
     <p:spTree>
       <p:nvGrpSpPr>
+        <p:cNvPr id="1" name="Shape"/>
+        <p:cNvGrpSpPr/>
+        <p:nvPr/>
+      </p:nvGrpSpPr>
+      <p:grpSpPr>
+        <a:xfrm>
+          <a:off x="0" y="0"/>
+          <a:ext cx="0" cy="0"/>
+          <a:chOff x="0" y="0"/>
+          <a:chExt cx="0" cy="0"/>
+        </a:xfrm>
+      </p:grpSpPr>
+      <p:sp>
+        <p:nvSpPr>
+          <p:cNvPr id="399" name="Title"/>
+          <p:cNvSpPr txBox="1">
+            <a:spLocks noGrp="1"/>
+          </p:cNvSpPr>
+          <p:nvPr>
+            <p:ph type="title"/>
+          </p:nvPr>
+        </p:nvSpPr>
+        <p:spPr>
+          <a:xfrm>
+            <a:off x="1297500" y="393750"/>
+            <a:ext cx="7038900" cy="914100"/>
+          </a:xfrm>
+          <a:prstGeom prst="rect">
+            <a:avLst/>
+          </a:prstGeom>
+        </p:spPr>
+        <p:txBody>
+          <a:bodyPr spcFirstLastPara="1" wrap="square" lIns="91425" tIns="91425" rIns="91425" bIns="91425" anchor="t" anchorCtr="0">
+            <a:normAutofit/>
+          </a:bodyPr>
+          <a:lstStyle/>
+          <a:p>
+            <a:pPr marL="0" lvl="0" indent="0" algn="l" rtl="0">
+              <a:spcBef>
+                <a:spcPts val="0"/>
+              </a:spcBef>
+              <a:spcAft>
+                <a:spcPts val="0"/>
+              </a:spcAft>
+              <a:buNone/>
+            </a:pPr>
+            <a:r>
+              <a:rPr lang="en-GB"/>
+              <a:t>Deep Learning Continued</a:t>
+            </a:r>
+            <a:endParaRPr/>
+          </a:p>
+        </p:txBody>
+      </p:sp>
+      <p:sp>
+        <p:nvSpPr>
+          <p:cNvPr id="400" name="TextBox 400"/>
+          <p:cNvSpPr txBox="1"/>
+          <p:nvPr/>
+        </p:nvSpPr>
+        <p:spPr>
+          <a:xfrm>
+            <a:off x="572000" y="1650000"/>
+            <a:ext cx="8000000" cy="900000"/>
+          </a:xfrm>
+          <a:prstGeom prst="roundRect">
+            <a:avLst>
+              <a:gd name="adj" fmla="val 8000"/>
+            </a:avLst>
+          </a:prstGeom>
+          <a:noFill/>
+          <a:ln>
+            <a:noFill/>
+          </a:ln>
+        </p:spPr>
+        <p:txBody>
+          <a:bodyPr spcFirstLastPara="1" wrap="square" lIns="91425" tIns="45700" rIns="91425" bIns="45700" anchor="t" anchorCtr="0">
+            <a:noAutofit/>
+          </a:bodyPr>
+          <a:lstStyle/>
+          <a:p>
+            <a:pPr marL="0" lvl="0" indent="0" algn="ctr" rtl="0">
+              <a:lnSpc>
+                <a:spcPct val="115000"/>
+              </a:lnSpc>
+              <a:spcBef>
+                <a:spcPts val="0"/>
+              </a:spcBef>
+              <a:spcAft>
+                <a:spcPts val="0"/>
+              </a:spcAft>
+              <a:buNone/>
+            </a:pPr>
+            <a:r>
+              <a:rPr lang="en-GB" sz="2400" b="1" dirty="0">
+                <a:solidFill>
+                  <a:schemeClr val="lt1"/>
+                </a:solidFill>
+              </a:rPr>
+              <a:t>97.2% vs 97.0% — a difference of two articles out of 932</a:t>
+            </a:r>
+            <a:endParaRPr sz="2400">
+              <a:solidFill>
+                <a:schemeClr val="lt1"/>
+              </a:solidFill>
+            </a:endParaRPr>
+          </a:p>
+        </p:txBody>
+      </p:sp>
+      <p:sp>
+        <p:nvSpPr>
+          <p:cNvPr id="401" name="TextBox 401"/>
+          <p:cNvSpPr txBox="1"/>
+          <p:nvPr/>
+        </p:nvSpPr>
+        <p:spPr>
+          <a:xfrm>
+            <a:off x="1072000" y="2560000"/>
+            <a:ext cx="7000000" cy="500000"/>
+          </a:xfrm>
+          <a:prstGeom prst="roundRect">
+            <a:avLst>
+              <a:gd name="adj" fmla="val 8000"/>
+            </a:avLst>
+          </a:prstGeom>
+          <a:noFill/>
+          <a:ln>
+            <a:noFill/>
+          </a:ln>
+        </p:spPr>
+        <p:txBody>
+          <a:bodyPr spcFirstLastPara="1" wrap="square" lIns="91425" tIns="45700" rIns="91425" bIns="45700" anchor="t" anchorCtr="0">
+            <a:noAutofit/>
+          </a:bodyPr>
+          <a:lstStyle/>
+          <a:p>
+            <a:pPr marL="0" lvl="0" indent="0" algn="ctr" rtl="0">
+              <a:lnSpc>
+                <a:spcPct val="115000"/>
+              </a:lnSpc>
+              <a:spcBef>
+                <a:spcPts val="0"/>
+              </a:spcBef>
+              <a:spcAft>
+                <a:spcPts val="0"/>
+              </a:spcAft>
+              <a:buNone/>
+            </a:pPr>
+            <a:r>
+              <a:rPr lang="en-GB" sz="1400" i="1" dirty="0">
+                <a:solidFill>
+                  <a:schemeClr val="lt1"/>
+                </a:solidFill>
+              </a:rPr>
+              <a:t>The honest reading: a 67M-parameter transformer and a linear model over word counts are tied.</a:t>
+            </a:r>
+            <a:endParaRPr sz="1400">
+              <a:solidFill>
+                <a:schemeClr val="lt1"/>
+              </a:solidFill>
+            </a:endParaRPr>
+          </a:p>
+        </p:txBody>
+      </p:sp>
+      <p:sp>
+        <p:nvSpPr>
+          <p:cNvPr id="402" name="TextBox 402"/>
+          <p:cNvSpPr txBox="1"/>
+          <p:nvPr/>
+        </p:nvSpPr>
+        <p:spPr>
+          <a:xfrm>
+            <a:off x="152000" y="3400000"/>
+            <a:ext cx="2800000" cy="1250000"/>
+          </a:xfrm>
+          <a:prstGeom prst="roundRect">
+            <a:avLst>
+              <a:gd name="adj" fmla="val 8000"/>
+            </a:avLst>
+          </a:prstGeom>
+          <a:solidFill>
+            <a:schemeClr val="lt2">
+              <a:alpha val="25000"/>
+            </a:schemeClr>
+          </a:solidFill>
+          <a:ln>
+            <a:noFill/>
+          </a:ln>
+        </p:spPr>
+        <p:txBody>
+          <a:bodyPr spcFirstLastPara="1" wrap="square" lIns="91425" tIns="45700" rIns="91425" bIns="45700" anchor="t" anchorCtr="0">
+            <a:noAutofit/>
+          </a:bodyPr>
+          <a:lstStyle/>
+          <a:p>
+            <a:pPr marL="0" lvl="0" indent="0" algn="ctr" rtl="0">
+              <a:lnSpc>
+                <a:spcPct val="115000"/>
+              </a:lnSpc>
+              <a:spcBef>
+                <a:spcPts val="0"/>
+              </a:spcBef>
+              <a:spcAft>
+                <a:spcPts val="400"/>
+              </a:spcAft>
+              <a:buNone/>
+            </a:pPr>
+            <a:r>
+              <a:rPr lang="en-GB" sz="1300" b="1" dirty="0">
+                <a:solidFill>
+                  <a:schemeClr val="lt1"/>
+                </a:solidFill>
+              </a:rPr>
+              <a:t>Pre-training does the work</a:t>
+            </a:r>
+            <a:endParaRPr sz="1300">
+              <a:solidFill>
+                <a:schemeClr val="lt1"/>
+              </a:solidFill>
+            </a:endParaRPr>
+          </a:p>
+          <a:p>
+            <a:pPr marL="0" lvl="0" indent="0" algn="ctr" rtl="0">
+              <a:lnSpc>
+                <a:spcPct val="115000"/>
+              </a:lnSpc>
+              <a:spcBef>
+                <a:spcPts val="0"/>
+              </a:spcBef>
+              <a:spcAft>
+                <a:spcPts val="400"/>
+              </a:spcAft>
+              <a:buNone/>
+            </a:pPr>
+            <a:r>
+              <a:rPr lang="en-GB" sz="1150" dirty="0">
+                <a:solidFill>
+                  <a:schemeClr val="lt1"/>
+                </a:solidFill>
+              </a:rPr>
+              <a:t>DistilBERT adapts representations learned on billions of words</a:t>
+            </a:r>
+            <a:endParaRPr sz="1150">
+              <a:solidFill>
+                <a:schemeClr val="lt1"/>
+              </a:solidFill>
+            </a:endParaRPr>
+          </a:p>
+        </p:txBody>
+      </p:sp>
+      <p:sp>
+        <p:nvSpPr>
+          <p:cNvPr id="403" name="TextBox 403"/>
+          <p:cNvSpPr txBox="1"/>
+          <p:nvPr/>
+        </p:nvSpPr>
+        <p:spPr>
+          <a:xfrm>
+            <a:off x="3172000" y="3400000"/>
+            <a:ext cx="2800000" cy="1250000"/>
+          </a:xfrm>
+          <a:prstGeom prst="roundRect">
+            <a:avLst>
+              <a:gd name="adj" fmla="val 8000"/>
+            </a:avLst>
+          </a:prstGeom>
+          <a:solidFill>
+            <a:schemeClr val="lt2">
+              <a:alpha val="25000"/>
+            </a:schemeClr>
+          </a:solidFill>
+          <a:ln>
+            <a:noFill/>
+          </a:ln>
+        </p:spPr>
+        <p:txBody>
+          <a:bodyPr spcFirstLastPara="1" wrap="square" lIns="91425" tIns="45700" rIns="91425" bIns="45700" anchor="t" anchorCtr="0">
+            <a:noAutofit/>
+          </a:bodyPr>
+          <a:lstStyle/>
+          <a:p>
+            <a:pPr marL="0" lvl="0" indent="0" algn="ctr" rtl="0">
+              <a:lnSpc>
+                <a:spcPct val="115000"/>
+              </a:lnSpc>
+              <a:spcBef>
+                <a:spcPts val="0"/>
+              </a:spcBef>
+              <a:spcAft>
+                <a:spcPts val="400"/>
+              </a:spcAft>
+              <a:buNone/>
+            </a:pPr>
+            <a:r>
+              <a:rPr lang="en-GB" sz="1300" b="1" dirty="0">
+                <a:solidFill>
+                  <a:schemeClr val="lt1"/>
+                </a:solidFill>
+              </a:rPr>
+              <a:t>From scratch is not enough</a:t>
+            </a:r>
+            <a:endParaRPr sz="1300">
+              <a:solidFill>
+                <a:schemeClr val="lt1"/>
+              </a:solidFill>
+            </a:endParaRPr>
+          </a:p>
+          <a:p>
+            <a:pPr marL="0" lvl="0" indent="0" algn="ctr" rtl="0">
+              <a:lnSpc>
+                <a:spcPct val="115000"/>
+              </a:lnSpc>
+              <a:spcBef>
+                <a:spcPts val="0"/>
+              </a:spcBef>
+              <a:spcAft>
+                <a:spcPts val="400"/>
+              </a:spcAft>
+              <a:buNone/>
+            </a:pPr>
+            <a:r>
+              <a:rPr lang="en-GB" sz="1150" dirty="0">
+                <a:solidFill>
+                  <a:schemeClr val="lt1"/>
+                </a:solidFill>
+              </a:rPr>
+              <a:t>the LSTM reaches 81.6% — beaten by Naive Bayes</a:t>
+            </a:r>
+            <a:endParaRPr sz="1150">
+              <a:solidFill>
+                <a:schemeClr val="lt1"/>
+              </a:solidFill>
+            </a:endParaRPr>
+          </a:p>
+        </p:txBody>
+      </p:sp>
+      <p:sp>
+        <p:nvSpPr>
+          <p:cNvPr id="404" name="TextBox 404"/>
+          <p:cNvSpPr txBox="1"/>
+          <p:nvPr/>
+        </p:nvSpPr>
+        <p:spPr>
+          <a:xfrm>
+            <a:off x="6192000" y="3400000"/>
+            <a:ext cx="2800000" cy="1250000"/>
+          </a:xfrm>
+          <a:prstGeom prst="roundRect">
+            <a:avLst>
+              <a:gd name="adj" fmla="val 8000"/>
+            </a:avLst>
+          </a:prstGeom>
+          <a:solidFill>
+            <a:schemeClr val="lt2">
+              <a:alpha val="25000"/>
+            </a:schemeClr>
+          </a:solidFill>
+          <a:ln>
+            <a:noFill/>
+          </a:ln>
+        </p:spPr>
+        <p:txBody>
+          <a:bodyPr spcFirstLastPara="1" wrap="square" lIns="91425" tIns="45700" rIns="91425" bIns="45700" anchor="t" anchorCtr="0">
+            <a:noAutofit/>
+          </a:bodyPr>
+          <a:lstStyle/>
+          <a:p>
+            <a:pPr marL="0" lvl="0" indent="0" algn="ctr" rtl="0">
+              <a:lnSpc>
+                <a:spcPct val="115000"/>
+              </a:lnSpc>
+              <a:spcBef>
+                <a:spcPts val="0"/>
+              </a:spcBef>
+              <a:spcAft>
+                <a:spcPts val="400"/>
+              </a:spcAft>
+              <a:buNone/>
+            </a:pPr>
+            <a:r>
+              <a:rPr lang="en-GB" sz="1300" b="1" dirty="0">
+                <a:solidFill>
+                  <a:schemeClr val="lt1"/>
+                </a:solidFill>
+              </a:rPr>
+              <a:t>No headroom left</a:t>
+            </a:r>
+            <a:endParaRPr sz="1300">
+              <a:solidFill>
+                <a:schemeClr val="lt1"/>
+              </a:solidFill>
+            </a:endParaRPr>
+          </a:p>
+          <a:p>
+            <a:pPr marL="0" lvl="0" indent="0" algn="ctr" rtl="0">
+              <a:lnSpc>
+                <a:spcPct val="115000"/>
+              </a:lnSpc>
+              <a:spcBef>
+                <a:spcPts val="0"/>
+              </a:spcBef>
+              <a:spcAft>
+                <a:spcPts val="400"/>
+              </a:spcAft>
+              <a:buNone/>
+            </a:pPr>
+            <a:r>
+              <a:rPr lang="en-GB" sz="1150" dirty="0">
+                <a:solidFill>
+                  <a:schemeClr val="lt1"/>
+                </a:solidFill>
+              </a:rPr>
+              <a:t>'shares' or 'scored' alone settles the category</a:t>
+            </a:r>
+            <a:endParaRPr sz="1150">
+              <a:solidFill>
+                <a:schemeClr val="lt1"/>
+              </a:solidFill>
+            </a:endParaRPr>
+          </a:p>
+        </p:txBody>
+      </p:sp>
+    </p:spTree>
+  </p:cSld>
+  <p:clrMapOvr>
+    <a:masterClrMapping/>
+  </p:clrMapOvr>
+</p:sld>
+</file>
+
+<file path=ppt/slides/slide11.xml><?xml version="1.0" encoding="utf-8"?>
+<p:sld xmlns:a="http://schemas.openxmlformats.org/drawingml/2006/main" xmlns:r="http://schemas.openxmlformats.org/officeDocument/2006/relationships" xmlns:p="http://schemas.openxmlformats.org/presentationml/2006/main">
+  <p:cSld>
+    <p:spTree>
+      <p:nvGrpSpPr>
         <p:cNvPr id="1" name="Shape 206"/>
         <p:cNvGrpSpPr/>
         <p:nvPr/>
@@ -10777,7 +11421,7 @@
 </p:sld>
 </file>
 
-<file path=ppt/slides/slide11.xml><?xml version="1.0" encoding="utf-8"?>
+<file path=ppt/slides/slide12.xml><?xml version="1.0" encoding="utf-8"?>
 <p:sld xmlns:a="http://schemas.openxmlformats.org/drawingml/2006/main" xmlns:r="http://schemas.openxmlformats.org/officeDocument/2006/relationships" xmlns:p="http://schemas.openxmlformats.org/presentationml/2006/main">
   <p:cSld>
     <p:spTree>
@@ -10794,62 +11438,9 @@
           <a:chExt cx="0" cy="0"/>
         </a:xfrm>
       </p:grpSpPr>
-      <p:pic>
-        <p:nvPicPr>
-          <p:cNvPr id="213" name="Google Shape;213;p23"/>
-          <p:cNvPicPr preferRelativeResize="0"/>
-          <p:nvPr/>
-        </p:nvPicPr>
-        <p:blipFill>
-          <a:blip r:embed="rId3">
-            <a:alphaModFix/>
-          </a:blip>
-          <a:stretch>
-            <a:fillRect/>
-          </a:stretch>
-        </p:blipFill>
-        <p:spPr>
-          <a:xfrm>
-            <a:off x="0" y="1871797"/>
-            <a:ext cx="9143999" cy="3271706"/>
-          </a:xfrm>
-          <a:prstGeom prst="rect">
-            <a:avLst/>
-          </a:prstGeom>
-          <a:noFill/>
-          <a:ln>
-            <a:noFill/>
-          </a:ln>
-        </p:spPr>
-      </p:pic>
-    </p:spTree>
-  </p:cSld>
-  <p:clrMapOvr>
-    <a:masterClrMapping/>
-  </p:clrMapOvr>
-</p:sld>
-</file>
-
-<file path=ppt/slides/slide12.xml><?xml version="1.0" encoding="utf-8"?>
-<p:sld xmlns:a="http://schemas.openxmlformats.org/drawingml/2006/main" xmlns:r="http://schemas.openxmlformats.org/officeDocument/2006/relationships" xmlns:p="http://schemas.openxmlformats.org/presentationml/2006/main">
-  <p:cSld>
-    <p:spTree>
-      <p:nvGrpSpPr>
-        <p:cNvPr id="1" name="Shape 217"/>
-        <p:cNvGrpSpPr/>
-        <p:nvPr/>
-      </p:nvGrpSpPr>
-      <p:grpSpPr>
-        <a:xfrm>
-          <a:off x="0" y="0"/>
-          <a:ext cx="0" cy="0"/>
-          <a:chOff x="0" y="0"/>
-          <a:chExt cx="0" cy="0"/>
-        </a:xfrm>
-      </p:grpSpPr>
       <p:sp>
         <p:nvSpPr>
-          <p:cNvPr id="218" name="Google Shape;218;p24"/>
+          <p:cNvPr id="500" name="Title 500"/>
           <p:cNvSpPr txBox="1">
             <a:spLocks noGrp="1"/>
           </p:cNvSpPr>
@@ -10883,7 +11474,7 @@
             </a:pPr>
             <a:r>
               <a:rPr lang="en-GB"/>
-              <a:t>RAG Continued</a:t>
+              <a:t>RAG — Evaluation Results</a:t>
             </a:r>
             <a:endParaRPr/>
           </a:p>
@@ -10891,18 +11482,178 @@
       </p:sp>
       <p:sp>
         <p:nvSpPr>
-          <p:cNvPr id="219" name="Google Shape;219;p24"/>
+          <p:cNvPr id="501" name="TextBox 501"/>
+          <p:cNvSpPr txBox="1"/>
+          <p:nvPr/>
+        </p:nvSpPr>
+        <p:spPr>
+          <a:xfrm>
+            <a:off x="1297500" y="1280000"/>
+            <a:ext cx="7038900" cy="950000"/>
+          </a:xfrm>
+          <a:prstGeom prst="rect">
+            <a:avLst/>
+          </a:prstGeom>
+          <a:noFill/>
+          <a:ln>
+            <a:noFill/>
+          </a:ln>
+        </p:spPr>
+        <p:txBody>
+          <a:bodyPr spcFirstLastPara="1" wrap="square" lIns="91425" tIns="45700" rIns="91425" bIns="45700" anchor="t" anchorCtr="0">
+            <a:noAutofit/>
+          </a:bodyPr>
+          <a:lstStyle/>
+          <a:p>
+            <a:pPr marL="0" lvl="0" indent="0" algn="l" rtl="0">
+              <a:lnSpc>
+                <a:spcPct val="115000"/>
+              </a:lnSpc>
+              <a:spcBef>
+                <a:spcPts val="0"/>
+              </a:spcBef>
+              <a:spcAft>
+                <a:spcPts val="400"/>
+              </a:spcAft>
+              <a:buNone/>
+            </a:pPr>
+            <a:r>
+              <a:rPr lang="en-GB" sz="1300" dirty="0">
+                <a:solidFill>
+                  <a:schemeClr val="lt1"/>
+                </a:solidFill>
+              </a:rPr>
+              <a:t>Mean ROUGE-L 0.155 · best 0.31 · two questions scored 0.0000</a:t>
+            </a:r>
+            <a:endParaRPr sz="1300" dirty="0">
+              <a:solidFill>
+                <a:schemeClr val="lt1"/>
+              </a:solidFill>
+            </a:endParaRPr>
+          </a:p>
+          <a:p>
+            <a:pPr marL="0" lvl="0" indent="0" algn="l" rtl="0">
+              <a:lnSpc>
+                <a:spcPct val="115000"/>
+              </a:lnSpc>
+              <a:spcBef>
+                <a:spcPts val="0"/>
+              </a:spcBef>
+              <a:spcAft>
+                <a:spcPts val="400"/>
+              </a:spcAft>
+              <a:buNone/>
+            </a:pPr>
+            <a:r>
+              <a:rPr lang="en-GB" sz="1300" dirty="0">
+                <a:solidFill>
+                  <a:schemeClr val="lt1"/>
+                </a:solidFill>
+              </a:rPr>
+              <a:t>'What sport does Tiger Woods play?' → 'golf' — correct, scored 0.0000</a:t>
+            </a:r>
+            <a:endParaRPr sz="1300" dirty="0">
+              <a:solidFill>
+                <a:schemeClr val="lt1"/>
+              </a:solidFill>
+            </a:endParaRPr>
+          </a:p>
+          <a:p>
+            <a:pPr marL="0" lvl="0" indent="0" algn="l" rtl="0">
+              <a:lnSpc>
+                <a:spcPct val="115000"/>
+              </a:lnSpc>
+              <a:spcBef>
+                <a:spcPts val="0"/>
+              </a:spcBef>
+              <a:spcAft>
+                <a:spcPts val="400"/>
+              </a:spcAft>
+              <a:buNone/>
+            </a:pPr>
+            <a:r>
+              <a:rPr lang="en-GB" sz="1300" dirty="0">
+                <a:solidFill>
+                  <a:schemeClr val="lt1"/>
+                </a:solidFill>
+              </a:rPr>
+              <a:t>Six of ten answers correct; the highest score any of them earned was 0.31</a:t>
+            </a:r>
+            <a:endParaRPr sz="1300" dirty="0">
+              <a:solidFill>
+                <a:schemeClr val="lt1"/>
+              </a:solidFill>
+            </a:endParaRPr>
+          </a:p>
+        </p:txBody>
+      </p:sp>
+      <p:pic>
+        <p:nvPicPr>
+          <p:cNvPr id="213" name="Google Shape;213;p23"/>
+          <p:cNvPicPr preferRelativeResize="0"/>
+          <p:nvPr/>
+        </p:nvPicPr>
+        <p:blipFill>
+          <a:blip r:embed="rId3">
+            <a:alphaModFix/>
+          </a:blip>
+          <a:stretch>
+            <a:fillRect/>
+          </a:stretch>
+        </p:blipFill>
+        <p:spPr>
+          <a:xfrm>
+            <a:off x="571200" y="2274000"/>
+            <a:ext cx="8001599" cy="2862900"/>
+          </a:xfrm>
+          <a:prstGeom prst="rect">
+            <a:avLst/>
+          </a:prstGeom>
+          <a:noFill/>
+          <a:ln>
+            <a:noFill/>
+          </a:ln>
+        </p:spPr>
+      </p:pic>
+    </p:spTree>
+  </p:cSld>
+  <p:clrMapOvr>
+    <a:masterClrMapping/>
+  </p:clrMapOvr>
+</p:sld>
+</file>
+
+<file path=ppt/slides/slide13.xml><?xml version="1.0" encoding="utf-8"?>
+<p:sld xmlns:a="http://schemas.openxmlformats.org/drawingml/2006/main" xmlns:r="http://schemas.openxmlformats.org/officeDocument/2006/relationships" xmlns:p="http://schemas.openxmlformats.org/presentationml/2006/main">
+  <p:cSld>
+    <p:spTree>
+      <p:nvGrpSpPr>
+        <p:cNvPr id="1" name="Shape"/>
+        <p:cNvGrpSpPr/>
+        <p:nvPr/>
+      </p:nvGrpSpPr>
+      <p:grpSpPr>
+        <a:xfrm>
+          <a:off x="0" y="0"/>
+          <a:ext cx="0" cy="0"/>
+          <a:chOff x="0" y="0"/>
+          <a:chExt cx="0" cy="0"/>
+        </a:xfrm>
+      </p:grpSpPr>
+      <p:sp>
+        <p:nvSpPr>
+          <p:cNvPr id="419" name="Title"/>
           <p:cNvSpPr txBox="1">
             <a:spLocks noGrp="1"/>
           </p:cNvSpPr>
           <p:nvPr>
-            <p:ph type="body" idx="1"/>
+            <p:ph type="title"/>
           </p:nvPr>
         </p:nvSpPr>
         <p:spPr>
           <a:xfrm>
-            <a:off x="0" y="1891925"/>
-            <a:ext cx="3038700" cy="3221700"/>
+            <a:off x="1297500" y="393750"/>
+            <a:ext cx="7038900" cy="914100"/>
           </a:xfrm>
           <a:prstGeom prst="rect">
             <a:avLst/>
@@ -10915,48 +11666,37 @@
           <a:lstStyle/>
           <a:p>
             <a:pPr marL="0" lvl="0" indent="0" algn="l" rtl="0">
-              <a:lnSpc>
-                <a:spcPct val="115000"/>
-              </a:lnSpc>
-              <a:spcBef>
-                <a:spcPts val="0"/>
-              </a:spcBef>
-              <a:spcAft>
-                <a:spcPts val="1200"/>
+              <a:spcBef>
+                <a:spcPts val="0"/>
+              </a:spcBef>
+              <a:spcAft>
+                <a:spcPts val="0"/>
               </a:spcAft>
               <a:buNone/>
             </a:pPr>
             <a:r>
-              <a:rPr lang="en-GB" sz="1200" dirty="0">
-                <a:latin typeface="Arial"/>
-                <a:ea typeface="Arial"/>
-                <a:cs typeface="Arial"/>
-                <a:sym typeface="Arial"/>
-              </a:rPr>
-              <a:t>Our reference for 'What sport does Tiger Woods play?' was the full sentence 'Tiger Woods is a professional golfer.' But an instruction-tuned model asked a direct question answers tersely — it says 'golf'. That answer is completely correct, and it scores exactly zero, because 'golf' and 'golfer' are different tokens with no common subsequence. Both of our zero-scoring questions are short-factoid questions of exactly that shape. </a:t>
+              <a:rPr lang="en-GB"/>
+              <a:t>RAG Continued</a:t>
             </a:r>
-            <a:endParaRPr sz="1200" dirty="0">
-              <a:latin typeface="Arial"/>
-              <a:ea typeface="Arial"/>
-              <a:cs typeface="Arial"/>
-              <a:sym typeface="Arial"/>
-            </a:endParaRPr>
+            <a:endParaRPr/>
           </a:p>
         </p:txBody>
       </p:sp>
       <p:sp>
         <p:nvSpPr>
-          <p:cNvPr id="220" name="Google Shape;220;p24"/>
+          <p:cNvPr id="420" name="TextBox 420"/>
           <p:cNvSpPr txBox="1"/>
           <p:nvPr/>
         </p:nvSpPr>
         <p:spPr>
           <a:xfrm>
-            <a:off x="1645400" y="1034675"/>
-            <a:ext cx="6830100" cy="240900"/>
+            <a:off x="572000" y="1400000"/>
+            <a:ext cx="8000000" cy="1000000"/>
           </a:xfrm>
-          <a:prstGeom prst="rect">
-            <a:avLst/>
+          <a:prstGeom prst="roundRect">
+            <a:avLst>
+              <a:gd name="adj" fmla="val 8000"/>
+            </a:avLst>
           </a:prstGeom>
           <a:noFill/>
           <a:ln>
@@ -10964,12 +11704,12 @@
           </a:ln>
         </p:spPr>
         <p:txBody>
-          <a:bodyPr spcFirstLastPara="1" wrap="square" lIns="91425" tIns="91425" rIns="91425" bIns="91425" anchor="t" anchorCtr="0">
+          <a:bodyPr spcFirstLastPara="1" wrap="square" lIns="91425" tIns="45700" rIns="91425" bIns="45700" anchor="t" anchorCtr="0">
             <a:noAutofit/>
           </a:bodyPr>
           <a:lstStyle/>
           <a:p>
-            <a:pPr marL="0" lvl="0" indent="0" algn="l" rtl="0">
+            <a:pPr marL="0" lvl="0" indent="0" algn="ctr" rtl="0">
               <a:lnSpc>
                 <a:spcPct val="115000"/>
               </a:lnSpc>
@@ -10977,59 +11717,68 @@
                 <a:spcPts val="0"/>
               </a:spcBef>
               <a:spcAft>
-                <a:spcPts val="1200"/>
+                <a:spcPts val="200"/>
               </a:spcAft>
               <a:buNone/>
             </a:pPr>
             <a:r>
-              <a:rPr lang="en-GB" sz="1200" dirty="0">
+              <a:rPr lang="en-GB" sz="1700" b="1" dirty="0">
                 <a:solidFill>
                   <a:schemeClr val="lt1"/>
                 </a:solidFill>
               </a:rPr>
-              <a:t>ROUGE-L scores the longest common subsequence against a reference answer — it rewards </a:t>
+              <a:t>One zero is the metric failing — the other is the system failing.</a:t>
             </a:r>
+            <a:endParaRPr sz="1700">
+              <a:solidFill>
+                <a:schemeClr val="lt1"/>
+              </a:solidFill>
+            </a:endParaRPr>
+          </a:p>
+          <a:p>
+            <a:pPr marL="0" lvl="0" indent="0" algn="ctr" rtl="0">
+              <a:lnSpc>
+                <a:spcPct val="115000"/>
+              </a:lnSpc>
+              <a:spcBef>
+                <a:spcPts val="0"/>
+              </a:spcBef>
+              <a:spcAft>
+                <a:spcPts val="200"/>
+              </a:spcAft>
+              <a:buNone/>
+            </a:pPr>
             <a:r>
-              <a:rPr lang="en-GB" sz="1200" i="1" dirty="0">
+              <a:rPr lang="en-GB" sz="1700" b="1" dirty="0">
                 <a:solidFill>
                   <a:schemeClr val="lt1"/>
                 </a:solidFill>
               </a:rPr>
-              <a:t>wording overlap</a:t>
+              <a:t>ROUGE-L gives them the same score: 0.0000</a:t>
             </a:r>
-            <a:r>
-              <a:rPr lang="en-GB" sz="1200" dirty="0">
-                <a:solidFill>
-                  <a:schemeClr val="lt1"/>
-                </a:solidFill>
-              </a:rPr>
-              <a:t> </a:t>
-            </a:r>
-            <a:endParaRPr sz="1200" dirty="0">
+            <a:endParaRPr sz="1700">
               <a:solidFill>
                 <a:schemeClr val="lt1"/>
               </a:solidFill>
-              <a:latin typeface="Lato"/>
-              <a:ea typeface="Lato"/>
-              <a:cs typeface="Lato"/>
-              <a:sym typeface="Lato"/>
             </a:endParaRPr>
           </a:p>
         </p:txBody>
       </p:sp>
       <p:sp>
         <p:nvSpPr>
-          <p:cNvPr id="221" name="Google Shape;221;p24"/>
+          <p:cNvPr id="421" name="TextBox 421"/>
           <p:cNvSpPr txBox="1"/>
           <p:nvPr/>
         </p:nvSpPr>
         <p:spPr>
           <a:xfrm>
-            <a:off x="0" y="1594975"/>
-            <a:ext cx="1361400" cy="324900"/>
+            <a:off x="142000" y="2750000"/>
+            <a:ext cx="2820000" cy="1900000"/>
           </a:xfrm>
-          <a:prstGeom prst="rect">
-            <a:avLst/>
+          <a:prstGeom prst="roundRect">
+            <a:avLst>
+              <a:gd name="adj" fmla="val 8000"/>
+            </a:avLst>
           </a:prstGeom>
           <a:noFill/>
           <a:ln>
@@ -11037,57 +11786,108 @@
           </a:ln>
         </p:spPr>
         <p:txBody>
-          <a:bodyPr spcFirstLastPara="1" wrap="square" lIns="91425" tIns="91425" rIns="91425" bIns="91425" anchor="t" anchorCtr="0">
+          <a:bodyPr spcFirstLastPara="1" wrap="square" lIns="91425" tIns="45700" rIns="91425" bIns="45700" anchor="t" anchorCtr="0">
             <a:noAutofit/>
           </a:bodyPr>
           <a:lstStyle/>
           <a:p>
-            <a:pPr marL="0" lvl="0" indent="0" algn="l" rtl="0">
-              <a:spcBef>
-                <a:spcPts val="0"/>
-              </a:spcBef>
-              <a:spcAft>
-                <a:spcPts val="0"/>
+            <a:pPr marL="0" lvl="0" indent="0" algn="ctr" rtl="0">
+              <a:lnSpc>
+                <a:spcPct val="115000"/>
+              </a:lnSpc>
+              <a:spcBef>
+                <a:spcPts val="0"/>
+              </a:spcBef>
+              <a:spcAft>
+                <a:spcPts val="400"/>
               </a:spcAft>
               <a:buNone/>
             </a:pPr>
             <a:r>
-              <a:rPr lang="en-GB" sz="1300" u="sng">
+              <a:rPr lang="en-GB" sz="1400" b="1" dirty="0">
                 <a:solidFill>
                   <a:schemeClr val="lt1"/>
                 </a:solidFill>
-                <a:latin typeface="Lato"/>
-                <a:ea typeface="Lato"/>
-                <a:cs typeface="Lato"/>
-                <a:sym typeface="Lato"/>
               </a:rPr>
-              <a:t>Instance 1</a:t>
+              <a:t>Metric failure</a:t>
             </a:r>
-            <a:endParaRPr sz="1300" u="sng">
+            <a:endParaRPr sz="1400">
               <a:solidFill>
                 <a:schemeClr val="lt1"/>
               </a:solidFill>
-              <a:latin typeface="Lato"/>
-              <a:ea typeface="Lato"/>
-              <a:cs typeface="Lato"/>
-              <a:sym typeface="Lato"/>
+            </a:endParaRPr>
+          </a:p>
+          <a:p>
+            <a:pPr marL="0" lvl="0" indent="0" algn="ctr" rtl="0">
+              <a:lnSpc>
+                <a:spcPct val="115000"/>
+              </a:lnSpc>
+              <a:spcBef>
+                <a:spcPts val="0"/>
+              </a:spcBef>
+              <a:spcAft>
+                <a:spcPts val="400"/>
+              </a:spcAft>
+              <a:buNone/>
+            </a:pPr>
+            <a:r>
+              <a:rPr lang="en-GB" sz="1250" dirty="0">
+                <a:solidFill>
+                  <a:schemeClr val="lt1"/>
+                </a:solidFill>
+              </a:rPr>
+              <a:t>'golf' — correct</a:t>
+            </a:r>
+            <a:endParaRPr sz="1250">
+              <a:solidFill>
+                <a:schemeClr val="lt1"/>
+              </a:solidFill>
+            </a:endParaRPr>
+          </a:p>
+          <a:p>
+            <a:pPr marL="0" lvl="0" indent="0" algn="ctr" rtl="0">
+              <a:lnSpc>
+                <a:spcPct val="115000"/>
+              </a:lnSpc>
+              <a:spcBef>
+                <a:spcPts val="0"/>
+              </a:spcBef>
+              <a:spcAft>
+                <a:spcPts val="400"/>
+              </a:spcAft>
+              <a:buNone/>
+            </a:pPr>
+            <a:r>
+              <a:rPr lang="en-GB" sz="1250" dirty="0">
+                <a:solidFill>
+                  <a:schemeClr val="lt1"/>
+                </a:solidFill>
+              </a:rPr>
+              <a:t>scored 0.0000</a:t>
+            </a:r>
+            <a:endParaRPr sz="1250">
+              <a:solidFill>
+                <a:schemeClr val="lt1"/>
+              </a:solidFill>
             </a:endParaRPr>
           </a:p>
         </p:txBody>
       </p:sp>
       <p:sp>
         <p:nvSpPr>
-          <p:cNvPr id="222" name="Google Shape;222;p24"/>
+          <p:cNvPr id="422" name="TextBox 422"/>
           <p:cNvSpPr txBox="1"/>
           <p:nvPr/>
         </p:nvSpPr>
         <p:spPr>
           <a:xfrm>
-            <a:off x="3186200" y="1594975"/>
-            <a:ext cx="2470800" cy="324900"/>
+            <a:off x="3162000" y="2750000"/>
+            <a:ext cx="2820000" cy="1900000"/>
           </a:xfrm>
-          <a:prstGeom prst="rect">
-            <a:avLst/>
+          <a:prstGeom prst="roundRect">
+            <a:avLst>
+              <a:gd name="adj" fmla="val 8000"/>
+            </a:avLst>
           </a:prstGeom>
           <a:noFill/>
           <a:ln>
@@ -11095,57 +11895,135 @@
           </a:ln>
         </p:spPr>
         <p:txBody>
-          <a:bodyPr spcFirstLastPara="1" wrap="square" lIns="91425" tIns="91425" rIns="91425" bIns="91425" anchor="t" anchorCtr="0">
+          <a:bodyPr spcFirstLastPara="1" wrap="square" lIns="91425" tIns="45700" rIns="91425" bIns="45700" anchor="t" anchorCtr="0">
             <a:noAutofit/>
           </a:bodyPr>
           <a:lstStyle/>
           <a:p>
-            <a:pPr marL="0" lvl="0" indent="0" algn="l" rtl="0">
-              <a:spcBef>
-                <a:spcPts val="0"/>
-              </a:spcBef>
-              <a:spcAft>
-                <a:spcPts val="0"/>
+            <a:pPr marL="0" lvl="0" indent="0" algn="ctr" rtl="0">
+              <a:lnSpc>
+                <a:spcPct val="115000"/>
+              </a:lnSpc>
+              <a:spcBef>
+                <a:spcPts val="0"/>
+              </a:spcBef>
+              <a:spcAft>
+                <a:spcPts val="400"/>
               </a:spcAft>
               <a:buNone/>
             </a:pPr>
             <a:r>
-              <a:rPr lang="en-GB" sz="1300" u="sng">
+              <a:rPr lang="en-GB" sz="1400" b="1" dirty="0">
                 <a:solidFill>
                   <a:schemeClr val="lt1"/>
                 </a:solidFill>
-                <a:latin typeface="Lato"/>
-                <a:ea typeface="Lato"/>
-                <a:cs typeface="Lato"/>
-                <a:sym typeface="Lato"/>
               </a:rPr>
-              <a:t>Instance 2</a:t>
+              <a:t>System failure</a:t>
             </a:r>
-            <a:endParaRPr sz="1300" u="sng">
+            <a:endParaRPr sz="1400">
               <a:solidFill>
                 <a:schemeClr val="lt1"/>
               </a:solidFill>
-              <a:latin typeface="Lato"/>
-              <a:ea typeface="Lato"/>
-              <a:cs typeface="Lato"/>
-              <a:sym typeface="Lato"/>
+            </a:endParaRPr>
+          </a:p>
+          <a:p>
+            <a:pPr marL="0" lvl="0" indent="0" algn="ctr" rtl="0">
+              <a:lnSpc>
+                <a:spcPct val="115000"/>
+              </a:lnSpc>
+              <a:spcBef>
+                <a:spcPts val="0"/>
+              </a:spcBef>
+              <a:spcAft>
+                <a:spcPts val="400"/>
+              </a:spcAft>
+              <a:buNone/>
+            </a:pPr>
+            <a:r>
+              <a:rPr lang="en-GB" sz="1250" dirty="0">
+                <a:solidFill>
+                  <a:schemeClr val="lt1"/>
+                </a:solidFill>
+              </a:rPr>
+              <a:t>'ivanovic' — wrong</a:t>
+            </a:r>
+            <a:endParaRPr sz="1250">
+              <a:solidFill>
+                <a:schemeClr val="lt1"/>
+              </a:solidFill>
+            </a:endParaRPr>
+          </a:p>
+          <a:p>
+            <a:pPr marL="0" lvl="0" indent="0" algn="ctr" rtl="0">
+              <a:lnSpc>
+                <a:spcPct val="115000"/>
+              </a:lnSpc>
+              <a:spcBef>
+                <a:spcPts val="0"/>
+              </a:spcBef>
+              <a:spcAft>
+                <a:spcPts val="400"/>
+              </a:spcAft>
+              <a:buNone/>
+            </a:pPr>
+            <a:r>
+              <a:rPr lang="en-GB" sz="1250" dirty="0">
+                <a:solidFill>
+                  <a:schemeClr val="lt1"/>
+                </a:solidFill>
+              </a:rPr>
+              <a:t>scored 0.0000</a:t>
+            </a:r>
+            <a:endParaRPr sz="1250">
+              <a:solidFill>
+                <a:schemeClr val="lt1"/>
+              </a:solidFill>
+            </a:endParaRPr>
+          </a:p>
+          <a:p>
+            <a:pPr marL="0" lvl="0" indent="0" algn="ctr" rtl="0">
+              <a:lnSpc>
+                <a:spcPct val="115000"/>
+              </a:lnSpc>
+              <a:spcBef>
+                <a:spcPts val="0"/>
+              </a:spcBef>
+              <a:spcAft>
+                <a:spcPts val="400"/>
+              </a:spcAft>
+              <a:buNone/>
+            </a:pPr>
+            <a:r>
+              <a:rPr lang="en-GB" sz="1250" dirty="0">
+                <a:solidFill>
+                  <a:schemeClr val="lt1"/>
+                </a:solidFill>
+              </a:rPr>
+              <a:t>4 of 10 answers wrong</a:t>
+            </a:r>
+            <a:endParaRPr sz="1250">
+              <a:solidFill>
+                <a:schemeClr val="lt1"/>
+              </a:solidFill>
             </a:endParaRPr>
           </a:p>
         </p:txBody>
       </p:sp>
       <p:sp>
         <p:nvSpPr>
-          <p:cNvPr id="223" name="Google Shape;223;p24"/>
+          <p:cNvPr id="423" name="TextBox 423"/>
           <p:cNvSpPr txBox="1"/>
           <p:nvPr/>
         </p:nvSpPr>
         <p:spPr>
           <a:xfrm>
-            <a:off x="3063050" y="1919875"/>
-            <a:ext cx="2980800" cy="3221700"/>
+            <a:off x="6182000" y="2750000"/>
+            <a:ext cx="2820000" cy="1900000"/>
           </a:xfrm>
-          <a:prstGeom prst="rect">
-            <a:avLst/>
+          <a:prstGeom prst="roundRect">
+            <a:avLst>
+              <a:gd name="adj" fmla="val 8000"/>
+            </a:avLst>
           </a:prstGeom>
           <a:noFill/>
           <a:ln>
@@ -11153,12 +12031,12 @@
           </a:ln>
         </p:spPr>
         <p:txBody>
-          <a:bodyPr spcFirstLastPara="1" wrap="square" lIns="91425" tIns="91425" rIns="91425" bIns="91425" anchor="t" anchorCtr="0">
+          <a:bodyPr spcFirstLastPara="1" wrap="square" lIns="91425" tIns="45700" rIns="91425" bIns="45700" anchor="t" anchorCtr="0">
             <a:noAutofit/>
           </a:bodyPr>
           <a:lstStyle/>
           <a:p>
-            <a:pPr marL="0" lvl="0" indent="0" algn="l" rtl="0">
+            <a:pPr marL="0" lvl="0" indent="0" algn="ctr" rtl="0">
               <a:lnSpc>
                 <a:spcPct val="115000"/>
               </a:lnSpc>
@@ -11166,56 +12044,26 @@
                 <a:spcPts val="0"/>
               </a:spcBef>
               <a:spcAft>
-                <a:spcPts val="0"/>
+                <a:spcPts val="400"/>
               </a:spcAft>
               <a:buNone/>
             </a:pPr>
             <a:r>
-              <a:rPr lang="en-GB" sz="1200" dirty="0">
+              <a:rPr lang="en-GB" sz="1400" b="1" dirty="0">
                 <a:solidFill>
                   <a:schemeClr val="lt1"/>
                 </a:solidFill>
               </a:rPr>
-              <a:t>We can check retrieval separately, and retrieval is sound. When we query 'Who won the football championship?', it returns two relevant football articles — and a review of the video game Championship Manager, tagged tech. That third hit isn't a bug; it's evidence the retriever is matching on meaning rather than keywords, because it understood 'championship' in a sense our query never disambiguated. </a:t>
+              <a:t>What we'd do instead</a:t>
             </a:r>
-            <a:endParaRPr sz="1200" dirty="0">
+            <a:endParaRPr sz="1400">
               <a:solidFill>
                 <a:schemeClr val="lt1"/>
               </a:solidFill>
-              <a:latin typeface="Lato"/>
-              <a:ea typeface="Lato"/>
-              <a:cs typeface="Lato"/>
-              <a:sym typeface="Lato"/>
             </a:endParaRPr>
           </a:p>
-        </p:txBody>
-      </p:sp>
-      <p:sp>
-        <p:nvSpPr>
-          <p:cNvPr id="224" name="Google Shape;224;p24"/>
-          <p:cNvSpPr txBox="1"/>
-          <p:nvPr/>
-        </p:nvSpPr>
-        <p:spPr>
-          <a:xfrm>
-            <a:off x="6060500" y="1891925"/>
-            <a:ext cx="3038700" cy="3251400"/>
-          </a:xfrm>
-          <a:prstGeom prst="rect">
-            <a:avLst/>
-          </a:prstGeom>
-          <a:noFill/>
-          <a:ln>
-            <a:noFill/>
-          </a:ln>
-        </p:spPr>
-        <p:txBody>
-          <a:bodyPr spcFirstLastPara="1" wrap="square" lIns="91425" tIns="91425" rIns="91425" bIns="91425" anchor="t" anchorCtr="0">
-            <a:noAutofit/>
-          </a:bodyPr>
-          <a:lstStyle/>
-          <a:p>
-            <a:pPr marL="0" lvl="0" indent="0" algn="l" rtl="0">
+          <a:p>
+            <a:pPr marL="0" lvl="0" indent="0" algn="ctr" rtl="0">
               <a:lnSpc>
                 <a:spcPct val="115000"/>
               </a:lnSpc>
@@ -11223,26 +12071,26 @@
                 <a:spcPts val="0"/>
               </a:spcBef>
               <a:spcAft>
-                <a:spcPts val="0"/>
+                <a:spcPts val="400"/>
               </a:spcAft>
               <a:buNone/>
             </a:pPr>
             <a:r>
-              <a:rPr lang="en-GB" sz="1200" dirty="0">
+              <a:rPr lang="en-GB" sz="1250" dirty="0">
                 <a:solidFill>
                   <a:schemeClr val="lt1"/>
                 </a:solidFill>
               </a:rPr>
-              <a:t>Flan-T5-base is small, so its answers are terse </a:t>
+              <a:t>Recall@k for retrieval</a:t>
             </a:r>
-            <a:endParaRPr sz="1200" dirty="0">
+            <a:endParaRPr sz="1250">
               <a:solidFill>
                 <a:schemeClr val="lt1"/>
               </a:solidFill>
             </a:endParaRPr>
           </a:p>
           <a:p>
-            <a:pPr marL="0" lvl="0" indent="0" algn="l" rtl="0">
+            <a:pPr marL="0" lvl="0" indent="0" algn="ctr" rtl="0">
               <a:lnSpc>
                 <a:spcPct val="115000"/>
               </a:lnSpc>
@@ -11250,114 +12098,36 @@
                 <a:spcPts val="0"/>
               </a:spcBef>
               <a:spcAft>
-                <a:spcPts val="0"/>
+                <a:spcPts val="400"/>
               </a:spcAft>
               <a:buNone/>
             </a:pPr>
             <a:r>
-              <a:rPr lang="en-GB" sz="1200" dirty="0">
+              <a:rPr lang="en-GB" sz="1250" dirty="0">
                 <a:solidFill>
                   <a:schemeClr val="lt1"/>
                 </a:solidFill>
               </a:rPr>
-              <a:t>some of our own questions aren't answerable from this corpus </a:t>
+              <a:t>BERTScore for answers</a:t>
             </a:r>
-            <a:endParaRPr sz="1200" dirty="0">
+            <a:endParaRPr sz="1250">
               <a:solidFill>
                 <a:schemeClr val="lt1"/>
               </a:solidFill>
             </a:endParaRPr>
           </a:p>
-          <a:p>
-            <a:pPr marL="0" lvl="0" indent="0" algn="l" rtl="0">
-              <a:lnSpc>
-                <a:spcPct val="115000"/>
-              </a:lnSpc>
-              <a:spcBef>
-                <a:spcPts val="0"/>
-              </a:spcBef>
-              <a:spcAft>
-                <a:spcPts val="0"/>
-              </a:spcAft>
-              <a:buNone/>
-            </a:pPr>
-            <a:r>
-              <a:rPr lang="en-GB" sz="1200" dirty="0">
-                <a:solidFill>
-                  <a:schemeClr val="lt1"/>
-                </a:solidFill>
-              </a:rPr>
-              <a:t>What we should have done is measure retrieval and generation separately </a:t>
-            </a:r>
-            <a:endParaRPr sz="1200" dirty="0">
-              <a:solidFill>
-                <a:schemeClr val="lt1"/>
-              </a:solidFill>
-            </a:endParaRPr>
-          </a:p>
-          <a:p>
-            <a:pPr marL="0" lvl="0" indent="0" algn="l" rtl="0">
-              <a:lnSpc>
-                <a:spcPct val="115000"/>
-              </a:lnSpc>
-              <a:spcBef>
-                <a:spcPts val="0"/>
-              </a:spcBef>
-              <a:spcAft>
-                <a:spcPts val="0"/>
-              </a:spcAft>
-              <a:buNone/>
-            </a:pPr>
-            <a:r>
-              <a:rPr lang="en-GB" sz="1200" dirty="0" err="1">
-                <a:solidFill>
-                  <a:schemeClr val="lt1"/>
-                </a:solidFill>
-              </a:rPr>
-              <a:t>Recall@k</a:t>
-            </a:r>
-            <a:r>
-              <a:rPr lang="en-GB" sz="1200" dirty="0">
-                <a:solidFill>
-                  <a:schemeClr val="lt1"/>
-                </a:solidFill>
-              </a:rPr>
-              <a:t> for the retriever — and score answers with something like </a:t>
-            </a:r>
-            <a:r>
-              <a:rPr lang="en-GB" sz="1200" dirty="0" err="1">
-                <a:solidFill>
-                  <a:schemeClr val="lt1"/>
-                </a:solidFill>
-              </a:rPr>
-              <a:t>BERTScore</a:t>
-            </a:r>
-            <a:r>
-              <a:rPr lang="en-GB" sz="1200" dirty="0">
-                <a:solidFill>
-                  <a:schemeClr val="lt1"/>
-                </a:solidFill>
-              </a:rPr>
-              <a:t> that credits correct paraphrases. </a:t>
-            </a:r>
-            <a:endParaRPr sz="1200" dirty="0">
-              <a:solidFill>
-                <a:schemeClr val="lt1"/>
-              </a:solidFill>
-            </a:endParaRPr>
-          </a:p>
         </p:txBody>
       </p:sp>
       <p:cxnSp>
         <p:nvCxnSpPr>
-          <p:cNvPr id="225" name="Google Shape;225;p24"/>
+          <p:cNvPr id="430" name="Line 430"/>
           <p:cNvCxnSpPr/>
           <p:nvPr/>
         </p:nvCxnSpPr>
         <p:spPr>
           <a:xfrm>
-            <a:off x="3057350" y="1684625"/>
-            <a:ext cx="5700" cy="3434700"/>
+            <a:off x="3062000" y="2750000"/>
+            <a:ext cx="5700" cy="1900000"/>
           </a:xfrm>
           <a:prstGeom prst="straightConnector1">
             <a:avLst/>
@@ -11376,14 +12146,14 @@
       </p:cxnSp>
       <p:cxnSp>
         <p:nvCxnSpPr>
-          <p:cNvPr id="226" name="Google Shape;226;p24"/>
+          <p:cNvPr id="431" name="Line 431"/>
           <p:cNvCxnSpPr/>
           <p:nvPr/>
         </p:nvCxnSpPr>
         <p:spPr>
           <a:xfrm>
-            <a:off x="6043700" y="1707025"/>
-            <a:ext cx="16800" cy="3417600"/>
+            <a:off x="6082000" y="2750000"/>
+            <a:ext cx="5700" cy="1900000"/>
           </a:xfrm>
           <a:prstGeom prst="straightConnector1">
             <a:avLst/>
@@ -11408,7 +12178,7 @@
 </p:sld>
 </file>
 
-<file path=ppt/slides/slide13.xml><?xml version="1.0" encoding="utf-8"?>
+<file path=ppt/slides/slide14.xml><?xml version="1.0" encoding="utf-8"?>
 <p:sld xmlns:a="http://schemas.openxmlformats.org/drawingml/2006/main" xmlns:r="http://schemas.openxmlformats.org/officeDocument/2006/relationships" xmlns:p="http://schemas.openxmlformats.org/presentationml/2006/main">
   <p:cSld>
     <p:spTree>
@@ -11480,7 +12250,7 @@
         <p:spPr>
           <a:xfrm>
             <a:off x="1297500" y="1567550"/>
-            <a:ext cx="7038900" cy="2911200"/>
+            <a:ext cx="7038900" cy="2240280"/>
           </a:xfrm>
           <a:prstGeom prst="rect">
             <a:avLst/>
@@ -11601,23 +12371,6 @@
                 <a:spcPts val="1200"/>
               </a:spcBef>
               <a:spcAft>
-                <a:spcPts val="0"/>
-              </a:spcAft>
-              <a:buNone/>
-            </a:pPr>
-            <a:endParaRPr sz="1200">
-              <a:latin typeface="Arial"/>
-              <a:ea typeface="Arial"/>
-              <a:cs typeface="Arial"/>
-              <a:sym typeface="Arial"/>
-            </a:endParaRPr>
-          </a:p>
-          <a:p>
-            <a:pPr marL="0" lvl="0" indent="0" algn="l" rtl="0">
-              <a:spcBef>
-                <a:spcPts val="1200"/>
-              </a:spcBef>
-              <a:spcAft>
                 <a:spcPts val="1200"/>
               </a:spcAft>
               <a:buNone/>
@@ -11640,6 +12393,54 @@
           </a:p>
         </p:txBody>
       </p:sp>
+      <p:pic>
+        <p:nvPicPr>
+          <p:cNvPr id="233" name="Picture 232" descr="image.png"/>
+          <p:cNvPicPr>
+            <a:picLocks noChangeAspect="1"/>
+          </p:cNvPicPr>
+          <p:nvPr/>
+        </p:nvPicPr>
+        <p:blipFill>
+          <a:blip r:embed="rId3"/>
+          <a:stretch>
+            <a:fillRect/>
+          </a:stretch>
+        </p:blipFill>
+        <p:spPr>
+          <a:xfrm>
+            <a:off x="848750" y="3602736"/>
+            <a:ext cx="3629505" cy="1408176"/>
+          </a:xfrm>
+          <a:prstGeom prst="rect">
+            <a:avLst/>
+          </a:prstGeom>
+        </p:spPr>
+      </p:pic>
+      <p:pic>
+        <p:nvPicPr>
+          <p:cNvPr id="234" name="Picture 233" descr="image.png"/>
+          <p:cNvPicPr>
+            <a:picLocks noChangeAspect="1"/>
+          </p:cNvPicPr>
+          <p:nvPr/>
+        </p:nvPicPr>
+        <p:blipFill>
+          <a:blip r:embed="rId4"/>
+          <a:stretch>
+            <a:fillRect/>
+          </a:stretch>
+        </p:blipFill>
+        <p:spPr>
+          <a:xfrm>
+            <a:off x="4752575" y="3602736"/>
+            <a:ext cx="3542674" cy="1408176"/>
+          </a:xfrm>
+          <a:prstGeom prst="rect">
+            <a:avLst/>
+          </a:prstGeom>
+        </p:spPr>
+      </p:pic>
     </p:spTree>
   </p:cSld>
   <p:clrMapOvr>
@@ -11648,12 +12449,12 @@
 </p:sld>
 </file>
 
-<file path=ppt/slides/slide14.xml><?xml version="1.0" encoding="utf-8"?>
+<file path=ppt/slides/slide15.xml><?xml version="1.0" encoding="utf-8"?>
 <p:sld xmlns:a="http://schemas.openxmlformats.org/drawingml/2006/main" xmlns:r="http://schemas.openxmlformats.org/officeDocument/2006/relationships" xmlns:p="http://schemas.openxmlformats.org/presentationml/2006/main">
   <p:cSld>
     <p:spTree>
       <p:nvGrpSpPr>
-        <p:cNvPr id="1" name="Shape 236"/>
+        <p:cNvPr id="1" name="Shape"/>
         <p:cNvGrpSpPr/>
         <p:nvPr/>
       </p:nvGrpSpPr>
@@ -11667,7 +12468,7 @@
       </p:grpSpPr>
       <p:sp>
         <p:nvSpPr>
-          <p:cNvPr id="237" name="Google Shape;237;p26"/>
+          <p:cNvPr id="439" name="Title"/>
           <p:cNvSpPr txBox="1">
             <a:spLocks noGrp="1"/>
           </p:cNvSpPr>
@@ -11709,238 +12510,344 @@
       </p:sp>
       <p:sp>
         <p:nvSpPr>
-          <p:cNvPr id="238" name="Google Shape;238;p26"/>
-          <p:cNvSpPr txBox="1">
-            <a:spLocks noGrp="1"/>
-          </p:cNvSpPr>
-          <p:nvPr>
-            <p:ph type="body" idx="1"/>
-          </p:nvPr>
+          <p:cNvPr id="440" name="TextBox 440"/>
+          <p:cNvSpPr txBox="1"/>
+          <p:nvPr/>
         </p:nvSpPr>
         <p:spPr>
           <a:xfrm>
-            <a:off x="1297500" y="1567550"/>
-            <a:ext cx="7038900" cy="3344400"/>
+            <a:off x="152000" y="1650000"/>
+            <a:ext cx="2800000" cy="1300000"/>
           </a:xfrm>
-          <a:prstGeom prst="rect">
-            <a:avLst/>
+          <a:prstGeom prst="roundRect">
+            <a:avLst>
+              <a:gd name="adj" fmla="val 8000"/>
+            </a:avLst>
           </a:prstGeom>
+          <a:solidFill>
+            <a:schemeClr val="lt2">
+              <a:alpha val="25000"/>
+            </a:schemeClr>
+          </a:solidFill>
+          <a:ln>
+            <a:noFill/>
+          </a:ln>
         </p:spPr>
         <p:txBody>
-          <a:bodyPr spcFirstLastPara="1" wrap="square" lIns="91425" tIns="91425" rIns="91425" bIns="91425" anchor="t" anchorCtr="0">
+          <a:bodyPr spcFirstLastPara="1" wrap="square" lIns="91425" tIns="45700" rIns="91425" bIns="45700" anchor="t" anchorCtr="0">
             <a:noAutofit/>
           </a:bodyPr>
           <a:lstStyle/>
           <a:p>
-            <a:pPr marL="0" lvl="0" indent="0" algn="l" rtl="0">
-              <a:spcBef>
-                <a:spcPts val="0"/>
-              </a:spcBef>
-              <a:spcAft>
-                <a:spcPts val="0"/>
+            <a:pPr marL="0" lvl="0" indent="0" algn="ctr" rtl="0">
+              <a:lnSpc>
+                <a:spcPct val="115000"/>
+              </a:lnSpc>
+              <a:spcBef>
+                <a:spcPts val="0"/>
+              </a:spcBef>
+              <a:spcAft>
+                <a:spcPts val="400"/>
               </a:spcAft>
               <a:buNone/>
             </a:pPr>
             <a:r>
-              <a:rPr lang="en-GB" sz="1200">
-                <a:latin typeface="Arial"/>
-                <a:ea typeface="Arial"/>
-                <a:cs typeface="Arial"/>
-                <a:sym typeface="Arial"/>
+              <a:rPr lang="en-GB" sz="1350" b="1" dirty="0">
+                <a:solidFill>
+                  <a:schemeClr val="lt1"/>
+                </a:solidFill>
               </a:rPr>
-              <a:t>Built a complete pipeline from raw text to a deployed, working chatbot.</a:t>
+              <a:t>Raw text → deployed chatbot</a:t>
             </a:r>
-            <a:endParaRPr sz="1200">
-              <a:latin typeface="Arial"/>
-              <a:ea typeface="Arial"/>
-              <a:cs typeface="Arial"/>
-              <a:sym typeface="Arial"/>
+            <a:endParaRPr sz="1350">
+              <a:solidFill>
+                <a:schemeClr val="lt1"/>
+              </a:solidFill>
             </a:endParaRPr>
           </a:p>
           <a:p>
-            <a:pPr marL="0" lvl="0" indent="0" algn="l" rtl="0">
-              <a:spcBef>
-                <a:spcPts val="1200"/>
-              </a:spcBef>
-              <a:spcAft>
-                <a:spcPts val="0"/>
+            <a:pPr marL="0" lvl="0" indent="0" algn="ctr" rtl="0">
+              <a:lnSpc>
+                <a:spcPct val="115000"/>
+              </a:lnSpc>
+              <a:spcBef>
+                <a:spcPts val="0"/>
+              </a:spcBef>
+              <a:spcAft>
+                <a:spcPts val="400"/>
               </a:spcAft>
               <a:buNone/>
             </a:pPr>
             <a:r>
-              <a:rPr lang="en-GB" sz="1200">
-                <a:latin typeface="Arial"/>
-                <a:ea typeface="Arial"/>
-                <a:cs typeface="Arial"/>
-                <a:sym typeface="Arial"/>
+              <a:rPr lang="en-GB" sz="1100" dirty="0">
+                <a:solidFill>
+                  <a:schemeClr val="lt1"/>
+                </a:solidFill>
               </a:rPr>
-              <a:t>Unsupervised topic discovery, three classical classifiers, two deep learning approaches, an explainability layer, and a retrieval-based question-answering system. </a:t>
+              <a:t>end-to-end, live on Streamlit</a:t>
             </a:r>
-            <a:endParaRPr sz="1200">
-              <a:latin typeface="Arial"/>
-              <a:ea typeface="Arial"/>
-              <a:cs typeface="Arial"/>
-              <a:sym typeface="Arial"/>
+            <a:endParaRPr sz="1100">
+              <a:solidFill>
+                <a:schemeClr val="lt1"/>
+              </a:solidFill>
             </a:endParaRPr>
           </a:p>
-          <a:p>
-            <a:pPr marL="0" lvl="0" indent="0" algn="l" rtl="0">
-              <a:spcBef>
-                <a:spcPts val="1200"/>
-              </a:spcBef>
-              <a:spcAft>
-                <a:spcPts val="0"/>
+        </p:txBody>
+      </p:sp>
+      <p:sp>
+        <p:nvSpPr>
+          <p:cNvPr id="441" name="TextBox 441"/>
+          <p:cNvSpPr txBox="1"/>
+          <p:nvPr/>
+        </p:nvSpPr>
+        <p:spPr>
+          <a:xfrm>
+            <a:off x="3172000" y="1650000"/>
+            <a:ext cx="2800000" cy="1300000"/>
+          </a:xfrm>
+          <a:prstGeom prst="roundRect">
+            <a:avLst>
+              <a:gd name="adj" fmla="val 8000"/>
+            </a:avLst>
+          </a:prstGeom>
+          <a:solidFill>
+            <a:schemeClr val="lt2">
+              <a:alpha val="25000"/>
+            </a:schemeClr>
+          </a:solidFill>
+          <a:ln>
+            <a:noFill/>
+          </a:ln>
+        </p:spPr>
+        <p:txBody>
+          <a:bodyPr spcFirstLastPara="1" wrap="square" lIns="91425" tIns="45700" rIns="91425" bIns="45700" anchor="t" anchorCtr="0">
+            <a:noAutofit/>
+          </a:bodyPr>
+          <a:lstStyle/>
+          <a:p>
+            <a:pPr marL="0" lvl="0" indent="0" algn="ctr" rtl="0">
+              <a:lnSpc>
+                <a:spcPct val="115000"/>
+              </a:lnSpc>
+              <a:spcBef>
+                <a:spcPts val="0"/>
+              </a:spcBef>
+              <a:spcAft>
+                <a:spcPts val="400"/>
               </a:spcAft>
               <a:buNone/>
             </a:pPr>
             <a:r>
-              <a:rPr lang="en-GB" sz="1200">
-                <a:latin typeface="Arial"/>
-                <a:ea typeface="Arial"/>
-                <a:cs typeface="Arial"/>
-                <a:sym typeface="Arial"/>
+              <a:rPr lang="en-GB" sz="1350" b="1" dirty="0">
+                <a:solidFill>
+                  <a:schemeClr val="lt1"/>
+                </a:solidFill>
               </a:rPr>
-              <a:t>Pre-training, not depth, is what separates these models </a:t>
+              <a:t>Seven techniques, one pipeline</a:t>
             </a:r>
-            <a:endParaRPr sz="1200">
-              <a:latin typeface="Arial"/>
-              <a:ea typeface="Arial"/>
-              <a:cs typeface="Arial"/>
-              <a:sym typeface="Arial"/>
+            <a:endParaRPr sz="1350">
+              <a:solidFill>
+                <a:schemeClr val="lt1"/>
+              </a:solidFill>
             </a:endParaRPr>
           </a:p>
           <a:p>
-            <a:pPr marL="0" lvl="0" indent="0" algn="l" rtl="0">
-              <a:spcBef>
-                <a:spcPts val="1200"/>
-              </a:spcBef>
-              <a:spcAft>
-                <a:spcPts val="0"/>
+            <a:pPr marL="0" lvl="0" indent="0" algn="ctr" rtl="0">
+              <a:lnSpc>
+                <a:spcPct val="115000"/>
+              </a:lnSpc>
+              <a:spcBef>
+                <a:spcPts val="0"/>
+              </a:spcBef>
+              <a:spcAft>
+                <a:spcPts val="400"/>
               </a:spcAft>
               <a:buNone/>
             </a:pPr>
             <a:r>
-              <a:rPr lang="en-GB" sz="1200">
-                <a:latin typeface="Arial"/>
-                <a:ea typeface="Arial"/>
-                <a:cs typeface="Arial"/>
-                <a:sym typeface="Arial"/>
+              <a:rPr lang="en-GB" sz="1100" dirty="0">
+                <a:solidFill>
+                  <a:schemeClr val="lt1"/>
+                </a:solidFill>
               </a:rPr>
-              <a:t>	The best model on the leaderboard isn't always the right model to ship. </a:t>
+              <a:t>topics · classifiers · deep learning · XAI · RAG</a:t>
             </a:r>
-            <a:endParaRPr sz="1200">
-              <a:latin typeface="Arial"/>
-              <a:ea typeface="Arial"/>
-              <a:cs typeface="Arial"/>
-              <a:sym typeface="Arial"/>
+            <a:endParaRPr sz="1100">
+              <a:solidFill>
+                <a:schemeClr val="lt1"/>
+              </a:solidFill>
             </a:endParaRPr>
           </a:p>
-          <a:p>
-            <a:pPr marL="0" lvl="0" indent="0" algn="l" rtl="0">
-              <a:spcBef>
-                <a:spcPts val="1200"/>
-              </a:spcBef>
-              <a:spcAft>
-                <a:spcPts val="0"/>
+        </p:txBody>
+      </p:sp>
+      <p:sp>
+        <p:nvSpPr>
+          <p:cNvPr id="442" name="TextBox 442"/>
+          <p:cNvSpPr txBox="1"/>
+          <p:nvPr/>
+        </p:nvSpPr>
+        <p:spPr>
+          <a:xfrm>
+            <a:off x="6192000" y="1650000"/>
+            <a:ext cx="2800000" cy="1300000"/>
+          </a:xfrm>
+          <a:prstGeom prst="roundRect">
+            <a:avLst>
+              <a:gd name="adj" fmla="val 8000"/>
+            </a:avLst>
+          </a:prstGeom>
+          <a:solidFill>
+            <a:schemeClr val="lt2">
+              <a:alpha val="25000"/>
+            </a:schemeClr>
+          </a:solidFill>
+          <a:ln>
+            <a:noFill/>
+          </a:ln>
+        </p:spPr>
+        <p:txBody>
+          <a:bodyPr spcFirstLastPara="1" wrap="square" lIns="91425" tIns="45700" rIns="91425" bIns="45700" anchor="t" anchorCtr="0">
+            <a:noAutofit/>
+          </a:bodyPr>
+          <a:lstStyle/>
+          <a:p>
+            <a:pPr marL="0" lvl="0" indent="0" algn="ctr" rtl="0">
+              <a:lnSpc>
+                <a:spcPct val="115000"/>
+              </a:lnSpc>
+              <a:spcBef>
+                <a:spcPts val="0"/>
+              </a:spcBef>
+              <a:spcAft>
+                <a:spcPts val="400"/>
               </a:spcAft>
               <a:buNone/>
             </a:pPr>
             <a:r>
-              <a:rPr lang="en-GB" sz="1200" b="1" u="sng">
-                <a:latin typeface="Arial"/>
-                <a:ea typeface="Arial"/>
-                <a:cs typeface="Arial"/>
-                <a:sym typeface="Arial"/>
+              <a:rPr lang="en-GB" sz="1350" b="1" dirty="0">
+                <a:solidFill>
+                  <a:schemeClr val="lt1"/>
+                </a:solidFill>
               </a:rPr>
-              <a:t>Future work </a:t>
+              <a:t>Pre-training, not depth</a:t>
             </a:r>
-            <a:endParaRPr sz="1200" b="1" u="sng">
-              <a:latin typeface="Arial"/>
-              <a:ea typeface="Arial"/>
-              <a:cs typeface="Arial"/>
-              <a:sym typeface="Arial"/>
+            <a:endParaRPr sz="1350">
+              <a:solidFill>
+                <a:schemeClr val="lt1"/>
+              </a:solidFill>
             </a:endParaRPr>
           </a:p>
           <a:p>
-            <a:pPr marL="0" lvl="0" indent="0" algn="l" rtl="0">
-              <a:spcBef>
-                <a:spcPts val="1200"/>
-              </a:spcBef>
-              <a:spcAft>
-                <a:spcPts val="0"/>
+            <a:pPr marL="0" lvl="0" indent="0" algn="ctr" rtl="0">
+              <a:lnSpc>
+                <a:spcPct val="115000"/>
+              </a:lnSpc>
+              <a:spcBef>
+                <a:spcPts val="0"/>
+              </a:spcBef>
+              <a:spcAft>
+                <a:spcPts val="400"/>
               </a:spcAft>
               <a:buNone/>
             </a:pPr>
             <a:r>
-              <a:rPr lang="en-GB" sz="1200">
-                <a:latin typeface="Arial"/>
-                <a:ea typeface="Arial"/>
-                <a:cs typeface="Arial"/>
-                <a:sym typeface="Arial"/>
+              <a:rPr lang="en-GB" sz="1100" dirty="0">
+                <a:solidFill>
+                  <a:schemeClr val="lt1"/>
+                </a:solidFill>
               </a:rPr>
-              <a:t>The cleanest next experiment is to initialise that same LSTM from pretrained GloVe or FastText embeddings</a:t>
+              <a:t>the leaderboard winner is not always the one to ship</a:t>
             </a:r>
-            <a:endParaRPr sz="1200">
-              <a:latin typeface="Arial"/>
-              <a:ea typeface="Arial"/>
-              <a:cs typeface="Arial"/>
-              <a:sym typeface="Arial"/>
+            <a:endParaRPr sz="1100">
+              <a:solidFill>
+                <a:schemeClr val="lt1"/>
+              </a:solidFill>
             </a:endParaRPr>
           </a:p>
-          <a:p>
-            <a:pPr marL="0" lvl="0" indent="0" algn="l" rtl="0">
-              <a:spcBef>
-                <a:spcPts val="1200"/>
-              </a:spcBef>
-              <a:spcAft>
-                <a:spcPts val="1200"/>
+        </p:txBody>
+      </p:sp>
+      <p:sp>
+        <p:nvSpPr>
+          <p:cNvPr id="450" name="TextBox 450"/>
+          <p:cNvSpPr txBox="1"/>
+          <p:nvPr/>
+        </p:nvSpPr>
+        <p:spPr>
+          <a:xfrm>
+            <a:off x="822000" y="3450000"/>
+            <a:ext cx="7500000" cy="1100000"/>
+          </a:xfrm>
+          <a:prstGeom prst="roundRect">
+            <a:avLst>
+              <a:gd name="adj" fmla="val 8000"/>
+            </a:avLst>
+          </a:prstGeom>
+          <a:noFill/>
+          <a:ln>
+            <a:noFill/>
+          </a:ln>
+        </p:spPr>
+        <p:txBody>
+          <a:bodyPr spcFirstLastPara="1" wrap="square" lIns="91425" tIns="45700" rIns="91425" bIns="45700" anchor="t" anchorCtr="0">
+            <a:noAutofit/>
+          </a:bodyPr>
+          <a:lstStyle/>
+          <a:p>
+            <a:pPr marL="0" lvl="0" indent="0" algn="ctr" rtl="0">
+              <a:lnSpc>
+                <a:spcPct val="115000"/>
+              </a:lnSpc>
+              <a:spcBef>
+                <a:spcPts val="0"/>
+              </a:spcBef>
+              <a:spcAft>
+                <a:spcPts val="500"/>
               </a:spcAft>
               <a:buNone/>
             </a:pPr>
             <a:r>
-              <a:rPr lang="en-GB" sz="1200">
-                <a:latin typeface="Arial"/>
-                <a:ea typeface="Arial"/>
-                <a:cs typeface="Arial"/>
-                <a:sym typeface="Arial"/>
+              <a:rPr lang="en-GB" sz="1400" b="1" dirty="0">
+                <a:solidFill>
+                  <a:schemeClr val="lt1"/>
+                </a:solidFill>
               </a:rPr>
-              <a:t>We'd also rebuild the RAG evaluation to measure retrieval and generation separately, and test our 'no headroom' explanation on a harder corpus — something like sarcasm or fine-grained sentiment.  </a:t>
+              <a:t>Future work</a:t>
             </a:r>
-            <a:endParaRPr sz="1200">
-              <a:latin typeface="Arial"/>
-              <a:ea typeface="Arial"/>
-              <a:cs typeface="Arial"/>
-              <a:sym typeface="Arial"/>
+            <a:endParaRPr sz="1400">
+              <a:solidFill>
+                <a:schemeClr val="lt1"/>
+              </a:solidFill>
+            </a:endParaRPr>
+          </a:p>
+          <a:p>
+            <a:pPr marL="0" lvl="0" indent="0" algn="ctr" rtl="0">
+              <a:lnSpc>
+                <a:spcPct val="115000"/>
+              </a:lnSpc>
+              <a:spcBef>
+                <a:spcPts val="0"/>
+              </a:spcBef>
+              <a:spcAft>
+                <a:spcPts val="500"/>
+              </a:spcAft>
+              <a:buNone/>
+            </a:pPr>
+            <a:r>
+              <a:rPr lang="en-GB" sz="1300" dirty="0">
+                <a:solidFill>
+                  <a:schemeClr val="lt1"/>
+                </a:solidFill>
+              </a:rPr>
+              <a:t>GloVe/FastText init for the LSTM · separate retrieval / generation eval · a harder corpus (sarcasm, fine-grained sentiment)</a:t>
+            </a:r>
+            <a:endParaRPr sz="1300">
+              <a:solidFill>
+                <a:schemeClr val="lt1"/>
+              </a:solidFill>
             </a:endParaRPr>
           </a:p>
         </p:txBody>
       </p:sp>
-      <p:cxnSp>
-        <p:nvCxnSpPr>
-          <p:cNvPr id="239" name="Google Shape;239;p26"/>
-          <p:cNvCxnSpPr/>
-          <p:nvPr/>
-        </p:nvCxnSpPr>
-        <p:spPr>
-          <a:xfrm rot="10800000">
-            <a:off x="25" y="3206125"/>
-            <a:ext cx="9136500" cy="24900"/>
-          </a:xfrm>
-          <a:prstGeom prst="straightConnector1">
-            <a:avLst/>
-          </a:prstGeom>
-          <a:noFill/>
-          <a:ln w="9525" cap="flat" cmpd="sng">
-            <a:solidFill>
-              <a:schemeClr val="dk2"/>
-            </a:solidFill>
-            <a:prstDash val="solid"/>
-            <a:round/>
-            <a:headEnd type="none" w="med" len="med"/>
-            <a:tailEnd type="none" w="med" len="med"/>
-          </a:ln>
-        </p:spPr>
-      </p:cxnSp>
     </p:spTree>
   </p:cSld>
   <p:clrMapOvr>
@@ -11949,7 +12856,7 @@
 </p:sld>
 </file>
 
-<file path=ppt/slides/slide15.xml><?xml version="1.0" encoding="utf-8"?>
+<file path=ppt/slides/slide16.xml><?xml version="1.0" encoding="utf-8"?>
 <p:sld xmlns:a="http://schemas.openxmlformats.org/drawingml/2006/main" xmlns:r="http://schemas.openxmlformats.org/officeDocument/2006/relationships" xmlns:p="http://schemas.openxmlformats.org/presentationml/2006/main">
   <p:cSld>
     <p:spTree>
@@ -12331,7 +13238,7 @@
   <p:cSld>
     <p:spTree>
       <p:nvGrpSpPr>
-        <p:cNvPr id="1" name="Shape 146"/>
+        <p:cNvPr id="1" name="Shape"/>
         <p:cNvGrpSpPr/>
         <p:nvPr/>
       </p:nvGrpSpPr>
@@ -12345,7 +13252,7 @@
       </p:grpSpPr>
       <p:sp>
         <p:nvSpPr>
-          <p:cNvPr id="147" name="Google Shape;147;p15"/>
+          <p:cNvPr id="299" name="Title"/>
           <p:cNvSpPr txBox="1">
             <a:spLocks noGrp="1"/>
           </p:cNvSpPr>
@@ -12387,142 +13294,373 @@
       </p:sp>
       <p:sp>
         <p:nvSpPr>
-          <p:cNvPr id="148" name="Google Shape;148;p15"/>
-          <p:cNvSpPr txBox="1">
-            <a:spLocks noGrp="1"/>
-          </p:cNvSpPr>
-          <p:nvPr>
-            <p:ph type="body" idx="1"/>
-          </p:nvPr>
-        </p:nvSpPr>
-        <p:spPr>
-          <a:xfrm>
-            <a:off x="300500" y="1432625"/>
-            <a:ext cx="2818500" cy="1826400"/>
-          </a:xfrm>
-          <a:prstGeom prst="rect">
-            <a:avLst/>
-          </a:prstGeom>
-        </p:spPr>
-        <p:txBody>
-          <a:bodyPr spcFirstLastPara="1" wrap="square" lIns="91425" tIns="91425" rIns="91425" bIns="91425" anchor="t" anchorCtr="0">
-            <a:normAutofit/>
-          </a:bodyPr>
-          <a:lstStyle/>
-          <a:p>
-            <a:pPr marL="457200" lvl="0" indent="-304800" algn="l" rtl="0">
-              <a:spcBef>
-                <a:spcPts val="0"/>
-              </a:spcBef>
-              <a:spcAft>
-                <a:spcPts val="0"/>
-              </a:spcAft>
-              <a:buSzPts val="1200"/>
-              <a:buFont typeface="Arial"/>
-              <a:buChar char="●"/>
-            </a:pPr>
-            <a:r>
-              <a:rPr lang="en-GB" sz="1200">
-                <a:latin typeface="Arial"/>
-                <a:ea typeface="Arial"/>
-                <a:cs typeface="Arial"/>
-                <a:sym typeface="Arial"/>
-              </a:rPr>
-              <a:t>Checked for missing values </a:t>
-            </a:r>
-            <a:endParaRPr sz="1200">
-              <a:latin typeface="Arial"/>
-              <a:ea typeface="Arial"/>
-              <a:cs typeface="Arial"/>
-              <a:sym typeface="Arial"/>
-            </a:endParaRPr>
-          </a:p>
-          <a:p>
-            <a:pPr marL="457200" lvl="0" indent="-304800" algn="l" rtl="0">
-              <a:spcBef>
-                <a:spcPts val="0"/>
-              </a:spcBef>
-              <a:spcAft>
-                <a:spcPts val="0"/>
-              </a:spcAft>
-              <a:buSzPts val="1200"/>
-              <a:buFont typeface="Arial"/>
-              <a:buChar char="●"/>
-            </a:pPr>
-            <a:r>
-              <a:rPr lang="en-GB" sz="1200">
-                <a:latin typeface="Arial"/>
-                <a:ea typeface="Arial"/>
-                <a:cs typeface="Arial"/>
-                <a:sym typeface="Arial"/>
-              </a:rPr>
-              <a:t>99 duplicate or near-duplicate articles </a:t>
-            </a:r>
-            <a:endParaRPr sz="1200">
-              <a:latin typeface="Arial"/>
-              <a:ea typeface="Arial"/>
-              <a:cs typeface="Arial"/>
-              <a:sym typeface="Arial"/>
-            </a:endParaRPr>
-          </a:p>
-          <a:p>
-            <a:pPr marL="457200" lvl="0" indent="-304800" algn="l" rtl="0">
-              <a:spcBef>
-                <a:spcPts val="0"/>
-              </a:spcBef>
-              <a:spcAft>
-                <a:spcPts val="0"/>
-              </a:spcAft>
-              <a:buSzPts val="1200"/>
-              <a:buFont typeface="Arial"/>
-              <a:buChar char="●"/>
-            </a:pPr>
-            <a:r>
-              <a:rPr lang="en-GB" sz="1200">
-                <a:latin typeface="Arial"/>
-                <a:ea typeface="Arial"/>
-                <a:cs typeface="Arial"/>
-                <a:sym typeface="Arial"/>
-              </a:rPr>
-              <a:t>That left 2,126 articles</a:t>
-            </a:r>
-            <a:r>
-              <a:rPr lang="en-GB" sz="1200">
-                <a:solidFill>
-                  <a:schemeClr val="dk1"/>
-                </a:solidFill>
-                <a:latin typeface="Arial"/>
-                <a:ea typeface="Arial"/>
-                <a:cs typeface="Arial"/>
-                <a:sym typeface="Arial"/>
-              </a:rPr>
-              <a:t> </a:t>
-            </a:r>
-            <a:endParaRPr sz="1200">
-              <a:solidFill>
-                <a:schemeClr val="dk1"/>
-              </a:solidFill>
-              <a:latin typeface="Arial"/>
-              <a:ea typeface="Arial"/>
-              <a:cs typeface="Arial"/>
-              <a:sym typeface="Arial"/>
-            </a:endParaRPr>
-          </a:p>
-        </p:txBody>
-      </p:sp>
-      <p:sp>
-        <p:nvSpPr>
-          <p:cNvPr id="149" name="Google Shape;149;p15"/>
+          <p:cNvPr id="300" name="TextBox 300"/>
           <p:cNvSpPr txBox="1"/>
           <p:nvPr/>
         </p:nvSpPr>
         <p:spPr>
           <a:xfrm>
-            <a:off x="4144300" y="1107525"/>
-            <a:ext cx="4583100" cy="2818200"/>
+            <a:off x="257000" y="1560000"/>
+            <a:ext cx="1330000" cy="620000"/>
           </a:xfrm>
-          <a:prstGeom prst="rect">
-            <a:avLst/>
+          <a:prstGeom prst="roundRect">
+            <a:avLst>
+              <a:gd name="adj" fmla="val 8000"/>
+            </a:avLst>
+          </a:prstGeom>
+          <a:solidFill>
+            <a:schemeClr val="lt2">
+              <a:alpha val="25000"/>
+            </a:schemeClr>
+          </a:solidFill>
+          <a:ln>
+            <a:noFill/>
+          </a:ln>
+        </p:spPr>
+        <p:txBody>
+          <a:bodyPr spcFirstLastPara="1" wrap="square" lIns="91425" tIns="45700" rIns="91425" bIns="45700" anchor="ctr" anchorCtr="0">
+            <a:noAutofit/>
+          </a:bodyPr>
+          <a:lstStyle/>
+          <a:p>
+            <a:pPr marL="0" lvl="0" indent="0" algn="ctr" rtl="0">
+              <a:lnSpc>
+                <a:spcPct val="115000"/>
+              </a:lnSpc>
+              <a:spcBef>
+                <a:spcPts val="0"/>
+              </a:spcBef>
+              <a:spcAft>
+                <a:spcPts val="0"/>
+              </a:spcAft>
+              <a:buNone/>
+            </a:pPr>
+            <a:r>
+              <a:rPr lang="en-GB" sz="1050" dirty="0">
+                <a:solidFill>
+                  <a:schemeClr val="lt1"/>
+                </a:solidFill>
+              </a:rPr>
+              <a:t>Lowercase</a:t>
+            </a:r>
+            <a:endParaRPr sz="1050">
+              <a:solidFill>
+                <a:schemeClr val="lt1"/>
+              </a:solidFill>
+            </a:endParaRPr>
+          </a:p>
+        </p:txBody>
+      </p:sp>
+      <p:sp>
+        <p:nvSpPr>
+          <p:cNvPr id="301" name="TextBox 301"/>
+          <p:cNvSpPr txBox="1"/>
+          <p:nvPr/>
+        </p:nvSpPr>
+        <p:spPr>
+          <a:xfrm>
+            <a:off x="1717000" y="1560000"/>
+            <a:ext cx="1330000" cy="620000"/>
+          </a:xfrm>
+          <a:prstGeom prst="roundRect">
+            <a:avLst>
+              <a:gd name="adj" fmla="val 8000"/>
+            </a:avLst>
+          </a:prstGeom>
+          <a:solidFill>
+            <a:schemeClr val="lt2">
+              <a:alpha val="25000"/>
+            </a:schemeClr>
+          </a:solidFill>
+          <a:ln>
+            <a:noFill/>
+          </a:ln>
+        </p:spPr>
+        <p:txBody>
+          <a:bodyPr spcFirstLastPara="1" wrap="square" lIns="91425" tIns="45700" rIns="91425" bIns="45700" anchor="ctr" anchorCtr="0">
+            <a:noAutofit/>
+          </a:bodyPr>
+          <a:lstStyle/>
+          <a:p>
+            <a:pPr marL="0" lvl="0" indent="0" algn="ctr" rtl="0">
+              <a:lnSpc>
+                <a:spcPct val="115000"/>
+              </a:lnSpc>
+              <a:spcBef>
+                <a:spcPts val="0"/>
+              </a:spcBef>
+              <a:spcAft>
+                <a:spcPts val="0"/>
+              </a:spcAft>
+              <a:buNone/>
+            </a:pPr>
+            <a:r>
+              <a:rPr lang="en-GB" sz="1050" dirty="0">
+                <a:solidFill>
+                  <a:schemeClr val="lt1"/>
+                </a:solidFill>
+              </a:rPr>
+              <a:t>Strip URLs &amp; HTML</a:t>
+            </a:r>
+            <a:endParaRPr sz="1050">
+              <a:solidFill>
+                <a:schemeClr val="lt1"/>
+              </a:solidFill>
+            </a:endParaRPr>
+          </a:p>
+        </p:txBody>
+      </p:sp>
+      <p:sp>
+        <p:nvSpPr>
+          <p:cNvPr id="302" name="TextBox 302"/>
+          <p:cNvSpPr txBox="1"/>
+          <p:nvPr/>
+        </p:nvSpPr>
+        <p:spPr>
+          <a:xfrm>
+            <a:off x="3177000" y="1560000"/>
+            <a:ext cx="1330000" cy="620000"/>
+          </a:xfrm>
+          <a:prstGeom prst="roundRect">
+            <a:avLst>
+              <a:gd name="adj" fmla="val 8000"/>
+            </a:avLst>
+          </a:prstGeom>
+          <a:solidFill>
+            <a:schemeClr val="lt2">
+              <a:alpha val="25000"/>
+            </a:schemeClr>
+          </a:solidFill>
+          <a:ln>
+            <a:noFill/>
+          </a:ln>
+        </p:spPr>
+        <p:txBody>
+          <a:bodyPr spcFirstLastPara="1" wrap="square" lIns="91425" tIns="45700" rIns="91425" bIns="45700" anchor="ctr" anchorCtr="0">
+            <a:noAutofit/>
+          </a:bodyPr>
+          <a:lstStyle/>
+          <a:p>
+            <a:pPr marL="0" lvl="0" indent="0" algn="ctr" rtl="0">
+              <a:lnSpc>
+                <a:spcPct val="115000"/>
+              </a:lnSpc>
+              <a:spcBef>
+                <a:spcPts val="0"/>
+              </a:spcBef>
+              <a:spcAft>
+                <a:spcPts val="0"/>
+              </a:spcAft>
+              <a:buNone/>
+            </a:pPr>
+            <a:r>
+              <a:rPr lang="en-GB" sz="1050" dirty="0">
+                <a:solidFill>
+                  <a:schemeClr val="lt1"/>
+                </a:solidFill>
+              </a:rPr>
+              <a:t>Expand contractions</a:t>
+            </a:r>
+            <a:endParaRPr sz="1050">
+              <a:solidFill>
+                <a:schemeClr val="lt1"/>
+              </a:solidFill>
+            </a:endParaRPr>
+          </a:p>
+        </p:txBody>
+      </p:sp>
+      <p:sp>
+        <p:nvSpPr>
+          <p:cNvPr id="303" name="TextBox 303"/>
+          <p:cNvSpPr txBox="1"/>
+          <p:nvPr/>
+        </p:nvSpPr>
+        <p:spPr>
+          <a:xfrm>
+            <a:off x="4637000" y="1560000"/>
+            <a:ext cx="1330000" cy="620000"/>
+          </a:xfrm>
+          <a:prstGeom prst="roundRect">
+            <a:avLst>
+              <a:gd name="adj" fmla="val 8000"/>
+            </a:avLst>
+          </a:prstGeom>
+          <a:solidFill>
+            <a:schemeClr val="lt2">
+              <a:alpha val="25000"/>
+            </a:schemeClr>
+          </a:solidFill>
+          <a:ln>
+            <a:noFill/>
+          </a:ln>
+        </p:spPr>
+        <p:txBody>
+          <a:bodyPr spcFirstLastPara="1" wrap="square" lIns="91425" tIns="45700" rIns="91425" bIns="45700" anchor="ctr" anchorCtr="0">
+            <a:noAutofit/>
+          </a:bodyPr>
+          <a:lstStyle/>
+          <a:p>
+            <a:pPr marL="0" lvl="0" indent="0" algn="ctr" rtl="0">
+              <a:lnSpc>
+                <a:spcPct val="115000"/>
+              </a:lnSpc>
+              <a:spcBef>
+                <a:spcPts val="0"/>
+              </a:spcBef>
+              <a:spcAft>
+                <a:spcPts val="0"/>
+              </a:spcAft>
+              <a:buNone/>
+            </a:pPr>
+            <a:r>
+              <a:rPr lang="en-GB" sz="1050" dirty="0">
+                <a:solidFill>
+                  <a:schemeClr val="lt1"/>
+                </a:solidFill>
+              </a:rPr>
+              <a:t>Remove punctuation</a:t>
+            </a:r>
+            <a:endParaRPr sz="1050">
+              <a:solidFill>
+                <a:schemeClr val="lt1"/>
+              </a:solidFill>
+            </a:endParaRPr>
+          </a:p>
+        </p:txBody>
+      </p:sp>
+      <p:sp>
+        <p:nvSpPr>
+          <p:cNvPr id="304" name="TextBox 304"/>
+          <p:cNvSpPr txBox="1"/>
+          <p:nvPr/>
+        </p:nvSpPr>
+        <p:spPr>
+          <a:xfrm>
+            <a:off x="6097000" y="1560000"/>
+            <a:ext cx="1330000" cy="620000"/>
+          </a:xfrm>
+          <a:prstGeom prst="roundRect">
+            <a:avLst>
+              <a:gd name="adj" fmla="val 8000"/>
+            </a:avLst>
+          </a:prstGeom>
+          <a:solidFill>
+            <a:schemeClr val="lt2">
+              <a:alpha val="25000"/>
+            </a:schemeClr>
+          </a:solidFill>
+          <a:ln>
+            <a:noFill/>
+          </a:ln>
+        </p:spPr>
+        <p:txBody>
+          <a:bodyPr spcFirstLastPara="1" wrap="square" lIns="91425" tIns="45700" rIns="91425" bIns="45700" anchor="ctr" anchorCtr="0">
+            <a:noAutofit/>
+          </a:bodyPr>
+          <a:lstStyle/>
+          <a:p>
+            <a:pPr marL="0" lvl="0" indent="0" algn="ctr" rtl="0">
+              <a:lnSpc>
+                <a:spcPct val="115000"/>
+              </a:lnSpc>
+              <a:spcBef>
+                <a:spcPts val="0"/>
+              </a:spcBef>
+              <a:spcAft>
+                <a:spcPts val="0"/>
+              </a:spcAft>
+              <a:buNone/>
+            </a:pPr>
+            <a:r>
+              <a:rPr lang="en-GB" sz="1050" dirty="0">
+                <a:solidFill>
+                  <a:schemeClr val="lt1"/>
+                </a:solidFill>
+              </a:rPr>
+              <a:t>Remove stopwords</a:t>
+            </a:r>
+            <a:endParaRPr sz="1050">
+              <a:solidFill>
+                <a:schemeClr val="lt1"/>
+              </a:solidFill>
+            </a:endParaRPr>
+          </a:p>
+        </p:txBody>
+      </p:sp>
+      <p:sp>
+        <p:nvSpPr>
+          <p:cNvPr id="305" name="TextBox 305"/>
+          <p:cNvSpPr txBox="1"/>
+          <p:nvPr/>
+        </p:nvSpPr>
+        <p:spPr>
+          <a:xfrm>
+            <a:off x="7557000" y="1560000"/>
+            <a:ext cx="1330000" cy="620000"/>
+          </a:xfrm>
+          <a:prstGeom prst="roundRect">
+            <a:avLst>
+              <a:gd name="adj" fmla="val 8000"/>
+            </a:avLst>
+          </a:prstGeom>
+          <a:solidFill>
+            <a:schemeClr val="lt2">
+              <a:alpha val="25000"/>
+            </a:schemeClr>
+          </a:solidFill>
+          <a:ln>
+            <a:noFill/>
+          </a:ln>
+        </p:spPr>
+        <p:txBody>
+          <a:bodyPr spcFirstLastPara="1" wrap="square" lIns="91425" tIns="45700" rIns="91425" bIns="45700" anchor="ctr" anchorCtr="0">
+            <a:noAutofit/>
+          </a:bodyPr>
+          <a:lstStyle/>
+          <a:p>
+            <a:pPr marL="0" lvl="0" indent="0" algn="ctr" rtl="0">
+              <a:lnSpc>
+                <a:spcPct val="115000"/>
+              </a:lnSpc>
+              <a:spcBef>
+                <a:spcPts val="0"/>
+              </a:spcBef>
+              <a:spcAft>
+                <a:spcPts val="0"/>
+              </a:spcAft>
+              <a:buNone/>
+            </a:pPr>
+            <a:r>
+              <a:rPr lang="en-GB" sz="1050" dirty="0">
+                <a:solidFill>
+                  <a:schemeClr val="lt1"/>
+                </a:solidFill>
+              </a:rPr>
+              <a:t>Lemmatise</a:t>
+            </a:r>
+            <a:endParaRPr sz="1050">
+              <a:solidFill>
+                <a:schemeClr val="lt1"/>
+              </a:solidFill>
+            </a:endParaRPr>
+          </a:p>
+        </p:txBody>
+      </p:sp>
+      <p:sp>
+        <p:nvSpPr>
+          <p:cNvPr id="310" name="TextBox 310"/>
+          <p:cNvSpPr txBox="1"/>
+          <p:nvPr/>
+        </p:nvSpPr>
+        <p:spPr>
+          <a:xfrm>
+            <a:off x="972000" y="2500000"/>
+            <a:ext cx="2400000" cy="1100000"/>
+          </a:xfrm>
+          <a:prstGeom prst="roundRect">
+            <a:avLst>
+              <a:gd name="adj" fmla="val 8000"/>
+            </a:avLst>
           </a:prstGeom>
           <a:noFill/>
           <a:ln>
@@ -12530,12 +13668,15 @@
           </a:ln>
         </p:spPr>
         <p:txBody>
-          <a:bodyPr spcFirstLastPara="1" wrap="square" lIns="91425" tIns="91425" rIns="91425" bIns="91425" anchor="t" anchorCtr="0">
+          <a:bodyPr spcFirstLastPara="1" wrap="square" lIns="91425" tIns="45700" rIns="91425" bIns="45700" anchor="t" anchorCtr="0">
             <a:noAutofit/>
           </a:bodyPr>
           <a:lstStyle/>
           <a:p>
-            <a:pPr marL="0" lvl="0" indent="0" algn="l" rtl="0">
+            <a:pPr marL="0" lvl="0" indent="0" algn="ctr" rtl="0">
+              <a:lnSpc>
+                <a:spcPct val="115000"/>
+              </a:lnSpc>
               <a:spcBef>
                 <a:spcPts val="0"/>
               </a:spcBef>
@@ -12545,20 +13686,39 @@
               <a:buNone/>
             </a:pPr>
             <a:r>
-              <a:rPr lang="en-GB" sz="1200">
+              <a:rPr lang="en-GB" sz="2800" b="1" dirty="0">
                 <a:solidFill>
                   <a:schemeClr val="lt1"/>
                 </a:solidFill>
               </a:rPr>
-              <a:t>We built a standard text-normalisation pipeline</a:t>
+              <a:t>0</a:t>
             </a:r>
+            <a:endParaRPr sz="2800">
+              <a:solidFill>
+                <a:schemeClr val="lt1"/>
+              </a:solidFill>
+            </a:endParaRPr>
+          </a:p>
+          <a:p>
+            <a:pPr marL="0" lvl="0" indent="0" algn="ctr" rtl="0">
+              <a:lnSpc>
+                <a:spcPct val="115000"/>
+              </a:lnSpc>
+              <a:spcBef>
+                <a:spcPts val="0"/>
+              </a:spcBef>
+              <a:spcAft>
+                <a:spcPts val="0"/>
+              </a:spcAft>
+              <a:buNone/>
+            </a:pPr>
             <a:r>
-              <a:rPr lang="en-GB" sz="1100">
+              <a:rPr lang="en-GB" sz="1100" dirty="0">
                 <a:solidFill>
                   <a:schemeClr val="lt1"/>
                 </a:solidFill>
               </a:rPr>
-              <a:t> </a:t>
+              <a:t>missing values</a:t>
             </a:r>
             <a:endParaRPr sz="1100">
               <a:solidFill>
@@ -12566,253 +13726,23 @@
               </a:solidFill>
             </a:endParaRPr>
           </a:p>
-          <a:p>
-            <a:pPr marL="457200" lvl="0" indent="-304800" algn="l" rtl="0">
-              <a:spcBef>
-                <a:spcPts val="0"/>
-              </a:spcBef>
-              <a:spcAft>
-                <a:spcPts val="0"/>
-              </a:spcAft>
-              <a:buClr>
-                <a:schemeClr val="lt1"/>
-              </a:buClr>
-              <a:buSzPts val="1200"/>
-              <a:buChar char="●"/>
-            </a:pPr>
-            <a:r>
-              <a:rPr lang="en-GB" sz="1200">
-                <a:solidFill>
-                  <a:schemeClr val="lt1"/>
-                </a:solidFill>
-              </a:rPr>
-              <a:t>Lowercase </a:t>
-            </a:r>
-            <a:endParaRPr sz="1200">
-              <a:solidFill>
-                <a:schemeClr val="lt1"/>
-              </a:solidFill>
-            </a:endParaRPr>
-          </a:p>
-          <a:p>
-            <a:pPr marL="457200" lvl="0" indent="-304800" algn="l" rtl="0">
-              <a:spcBef>
-                <a:spcPts val="0"/>
-              </a:spcBef>
-              <a:spcAft>
-                <a:spcPts val="0"/>
-              </a:spcAft>
-              <a:buClr>
-                <a:schemeClr val="lt1"/>
-              </a:buClr>
-              <a:buSzPts val="1200"/>
-              <a:buChar char="●"/>
-            </a:pPr>
-            <a:r>
-              <a:rPr lang="en-GB" sz="1200">
-                <a:solidFill>
-                  <a:schemeClr val="lt1"/>
-                </a:solidFill>
-              </a:rPr>
-              <a:t>Strip URLs and HTML tags </a:t>
-            </a:r>
-            <a:endParaRPr sz="1200">
-              <a:solidFill>
-                <a:schemeClr val="lt1"/>
-              </a:solidFill>
-            </a:endParaRPr>
-          </a:p>
-          <a:p>
-            <a:pPr marL="457200" lvl="0" indent="-304800" algn="l" rtl="0">
-              <a:spcBef>
-                <a:spcPts val="0"/>
-              </a:spcBef>
-              <a:spcAft>
-                <a:spcPts val="0"/>
-              </a:spcAft>
-              <a:buClr>
-                <a:schemeClr val="lt1"/>
-              </a:buClr>
-              <a:buSzPts val="1200"/>
-              <a:buChar char="●"/>
-            </a:pPr>
-            <a:r>
-              <a:rPr lang="en-GB" sz="1200">
-                <a:solidFill>
-                  <a:schemeClr val="lt1"/>
-                </a:solidFill>
-              </a:rPr>
-              <a:t>Expand contractions </a:t>
-            </a:r>
-            <a:endParaRPr sz="1200">
-              <a:solidFill>
-                <a:schemeClr val="lt1"/>
-              </a:solidFill>
-            </a:endParaRPr>
-          </a:p>
-          <a:p>
-            <a:pPr marL="457200" lvl="0" indent="-304800" algn="l" rtl="0">
-              <a:spcBef>
-                <a:spcPts val="0"/>
-              </a:spcBef>
-              <a:spcAft>
-                <a:spcPts val="0"/>
-              </a:spcAft>
-              <a:buClr>
-                <a:schemeClr val="lt1"/>
-              </a:buClr>
-              <a:buSzPts val="1200"/>
-              <a:buChar char="●"/>
-            </a:pPr>
-            <a:r>
-              <a:rPr lang="en-GB" sz="1200">
-                <a:solidFill>
-                  <a:schemeClr val="lt1"/>
-                </a:solidFill>
-              </a:rPr>
-              <a:t>Remove punctuation </a:t>
-            </a:r>
-            <a:endParaRPr sz="1200">
-              <a:solidFill>
-                <a:schemeClr val="lt1"/>
-              </a:solidFill>
-            </a:endParaRPr>
-          </a:p>
-          <a:p>
-            <a:pPr marL="457200" lvl="0" indent="-304800" algn="l" rtl="0">
-              <a:spcBef>
-                <a:spcPts val="0"/>
-              </a:spcBef>
-              <a:spcAft>
-                <a:spcPts val="0"/>
-              </a:spcAft>
-              <a:buClr>
-                <a:schemeClr val="lt1"/>
-              </a:buClr>
-              <a:buSzPts val="1200"/>
-              <a:buChar char="●"/>
-            </a:pPr>
-            <a:r>
-              <a:rPr lang="en-GB" sz="1200">
-                <a:solidFill>
-                  <a:schemeClr val="lt1"/>
-                </a:solidFill>
-              </a:rPr>
-              <a:t>Remove stopwords </a:t>
-            </a:r>
-            <a:endParaRPr sz="1200">
-              <a:solidFill>
-                <a:schemeClr val="lt1"/>
-              </a:solidFill>
-            </a:endParaRPr>
-          </a:p>
-          <a:p>
-            <a:pPr marL="457200" lvl="0" indent="-304800" algn="l" rtl="0">
-              <a:spcBef>
-                <a:spcPts val="0"/>
-              </a:spcBef>
-              <a:spcAft>
-                <a:spcPts val="0"/>
-              </a:spcAft>
-              <a:buClr>
-                <a:schemeClr val="lt1"/>
-              </a:buClr>
-              <a:buSzPts val="1200"/>
-              <a:buChar char="●"/>
-            </a:pPr>
-            <a:r>
-              <a:rPr lang="en-GB" sz="1200">
-                <a:solidFill>
-                  <a:schemeClr val="lt1"/>
-                </a:solidFill>
-              </a:rPr>
-              <a:t>Lemmatise </a:t>
-            </a:r>
-            <a:endParaRPr sz="1200">
-              <a:solidFill>
-                <a:schemeClr val="lt1"/>
-              </a:solidFill>
-            </a:endParaRPr>
-          </a:p>
-          <a:p>
-            <a:pPr marL="0" lvl="0" indent="0" algn="l" rtl="0">
-              <a:spcBef>
-                <a:spcPts val="0"/>
-              </a:spcBef>
-              <a:spcAft>
-                <a:spcPts val="0"/>
-              </a:spcAft>
-              <a:buNone/>
-            </a:pPr>
-            <a:endParaRPr sz="1100">
-              <a:solidFill>
-                <a:schemeClr val="lt1"/>
-              </a:solidFill>
-            </a:endParaRPr>
-          </a:p>
-          <a:p>
-            <a:pPr marL="0" lvl="0" indent="0" algn="l" rtl="0">
-              <a:spcBef>
-                <a:spcPts val="0"/>
-              </a:spcBef>
-              <a:spcAft>
-                <a:spcPts val="0"/>
-              </a:spcAft>
-              <a:buNone/>
-            </a:pPr>
-            <a:endParaRPr sz="1100">
-              <a:solidFill>
-                <a:schemeClr val="lt1"/>
-              </a:solidFill>
-            </a:endParaRPr>
-          </a:p>
-          <a:p>
-            <a:pPr marL="0" lvl="0" indent="0" algn="l" rtl="0">
-              <a:spcBef>
-                <a:spcPts val="0"/>
-              </a:spcBef>
-              <a:spcAft>
-                <a:spcPts val="0"/>
-              </a:spcAft>
-              <a:buNone/>
-            </a:pPr>
-            <a:r>
-              <a:rPr lang="en-GB" sz="1200">
-                <a:solidFill>
-                  <a:schemeClr val="lt1"/>
-                </a:solidFill>
-              </a:rPr>
-              <a:t>We chose lemmatisation over stemming deliberately: stemming can mangle words into non-words, which hurts readability of everything downstream, especially our topic model's keyword lists and our word-embedding neighbours.</a:t>
-            </a:r>
-            <a:r>
-              <a:rPr lang="en-GB" sz="1100">
-                <a:solidFill>
-                  <a:schemeClr val="dk1"/>
-                </a:solidFill>
-              </a:rPr>
-              <a:t> </a:t>
-            </a:r>
-            <a:endParaRPr sz="1100">
-              <a:solidFill>
-                <a:schemeClr val="dk1"/>
-              </a:solidFill>
-            </a:endParaRPr>
-          </a:p>
         </p:txBody>
       </p:sp>
       <p:sp>
         <p:nvSpPr>
-          <p:cNvPr id="150" name="Google Shape;150;p15"/>
+          <p:cNvPr id="311" name="TextBox 311"/>
           <p:cNvSpPr txBox="1"/>
           <p:nvPr/>
         </p:nvSpPr>
         <p:spPr>
           <a:xfrm>
-            <a:off x="171825" y="3976225"/>
-            <a:ext cx="8972100" cy="1167300"/>
+            <a:off x="3372000" y="2500000"/>
+            <a:ext cx="2400000" cy="1100000"/>
           </a:xfrm>
-          <a:prstGeom prst="rect">
-            <a:avLst/>
+          <a:prstGeom prst="roundRect">
+            <a:avLst>
+              <a:gd name="adj" fmla="val 8000"/>
+            </a:avLst>
           </a:prstGeom>
           <a:noFill/>
           <a:ln>
@@ -12820,12 +13750,15 @@
           </a:ln>
         </p:spPr>
         <p:txBody>
-          <a:bodyPr spcFirstLastPara="1" wrap="square" lIns="91425" tIns="91425" rIns="91425" bIns="91425" anchor="t" anchorCtr="0">
+          <a:bodyPr spcFirstLastPara="1" wrap="square" lIns="91425" tIns="45700" rIns="91425" bIns="45700" anchor="t" anchorCtr="0">
             <a:noAutofit/>
           </a:bodyPr>
           <a:lstStyle/>
           <a:p>
-            <a:pPr marL="0" lvl="0" indent="0" algn="l" rtl="0">
+            <a:pPr marL="0" lvl="0" indent="0" algn="ctr" rtl="0">
+              <a:lnSpc>
+                <a:spcPct val="115000"/>
+              </a:lnSpc>
               <a:spcBef>
                 <a:spcPts val="0"/>
               </a:spcBef>
@@ -12835,21 +13768,24 @@
               <a:buNone/>
             </a:pPr>
             <a:r>
-              <a:rPr lang="en-GB" sz="1200">
+              <a:rPr lang="en-GB" sz="2800" b="1" dirty="0">
                 <a:solidFill>
-                  <a:srgbClr val="F0F6FC"/>
+                  <a:schemeClr val="lt1"/>
                 </a:solidFill>
               </a:rPr>
-              <a:t>Kept two versions of the text throughout the whole project, the original raw text, and this cleaned version. </a:t>
+              <a:t>− 99</a:t>
             </a:r>
-            <a:endParaRPr sz="1200">
+            <a:endParaRPr sz="2800">
               <a:solidFill>
-                <a:srgbClr val="F0F6FC"/>
+                <a:schemeClr val="lt1"/>
               </a:solidFill>
             </a:endParaRPr>
           </a:p>
           <a:p>
-            <a:pPr marL="0" lvl="0" indent="0" algn="l" rtl="0">
+            <a:pPr marL="0" lvl="0" indent="0" algn="ctr" rtl="0">
+              <a:lnSpc>
+                <a:spcPct val="115000"/>
+              </a:lnSpc>
               <a:spcBef>
                 <a:spcPts val="0"/>
               </a:spcBef>
@@ -12858,14 +13794,53 @@
               </a:spcAft>
               <a:buNone/>
             </a:pPr>
-            <a:endParaRPr sz="1200">
+            <a:r>
+              <a:rPr lang="en-GB" sz="1100" dirty="0">
+                <a:solidFill>
+                  <a:schemeClr val="lt1"/>
+                </a:solidFill>
+              </a:rPr>
+              <a:t>duplicates removed</a:t>
+            </a:r>
+            <a:endParaRPr sz="1100">
               <a:solidFill>
-                <a:srgbClr val="F0F6FC"/>
+                <a:schemeClr val="lt1"/>
               </a:solidFill>
             </a:endParaRPr>
           </a:p>
-          <a:p>
-            <a:pPr marL="0" lvl="0" indent="0" algn="l" rtl="0">
+        </p:txBody>
+      </p:sp>
+      <p:sp>
+        <p:nvSpPr>
+          <p:cNvPr id="312" name="TextBox 312"/>
+          <p:cNvSpPr txBox="1"/>
+          <p:nvPr/>
+        </p:nvSpPr>
+        <p:spPr>
+          <a:xfrm>
+            <a:off x="5772000" y="2500000"/>
+            <a:ext cx="2400000" cy="1100000"/>
+          </a:xfrm>
+          <a:prstGeom prst="roundRect">
+            <a:avLst>
+              <a:gd name="adj" fmla="val 8000"/>
+            </a:avLst>
+          </a:prstGeom>
+          <a:noFill/>
+          <a:ln>
+            <a:noFill/>
+          </a:ln>
+        </p:spPr>
+        <p:txBody>
+          <a:bodyPr spcFirstLastPara="1" wrap="square" lIns="91425" tIns="45700" rIns="91425" bIns="45700" anchor="t" anchorCtr="0">
+            <a:noAutofit/>
+          </a:bodyPr>
+          <a:lstStyle/>
+          <a:p>
+            <a:pPr marL="0" lvl="0" indent="0" algn="ctr" rtl="0">
+              <a:lnSpc>
+                <a:spcPct val="115000"/>
+              </a:lnSpc>
               <a:spcBef>
                 <a:spcPts val="0"/>
               </a:spcBef>
@@ -12875,81 +13850,130 @@
               <a:buNone/>
             </a:pPr>
             <a:r>
-              <a:rPr lang="en-GB" sz="1200">
+              <a:rPr lang="en-GB" sz="2800" b="1" dirty="0">
                 <a:solidFill>
-                  <a:srgbClr val="F0F6FC"/>
+                  <a:schemeClr val="lt1"/>
                 </a:solidFill>
               </a:rPr>
-              <a:t>Our from-scratch models want the cleaned version, but our pretrained transformer model, DistilBERT, performs better on the original, uncleaned text, because it has its own subword tokenizer that already knows how to handle punctuation and capitalisation.</a:t>
+              <a:t>2,126</a:t>
             </a:r>
+            <a:endParaRPr sz="2800">
+              <a:solidFill>
+                <a:schemeClr val="lt1"/>
+              </a:solidFill>
+            </a:endParaRPr>
+          </a:p>
+          <a:p>
+            <a:pPr marL="0" lvl="0" indent="0" algn="ctr" rtl="0">
+              <a:lnSpc>
+                <a:spcPct val="115000"/>
+              </a:lnSpc>
+              <a:spcBef>
+                <a:spcPts val="0"/>
+              </a:spcBef>
+              <a:spcAft>
+                <a:spcPts val="0"/>
+              </a:spcAft>
+              <a:buNone/>
+            </a:pPr>
             <a:r>
-              <a:rPr lang="en-GB" sz="1200">
+              <a:rPr lang="en-GB" sz="1100" dirty="0">
                 <a:solidFill>
-                  <a:schemeClr val="dk1"/>
+                  <a:schemeClr val="lt1"/>
                 </a:solidFill>
               </a:rPr>
-              <a:t> </a:t>
+              <a:t>articles kept</a:t>
             </a:r>
-            <a:endParaRPr sz="1200">
+            <a:endParaRPr sz="1100">
               <a:solidFill>
-                <a:schemeClr val="dk2"/>
+                <a:schemeClr val="lt1"/>
               </a:solidFill>
             </a:endParaRPr>
           </a:p>
         </p:txBody>
       </p:sp>
-      <p:cxnSp>
-        <p:nvCxnSpPr>
-          <p:cNvPr id="151" name="Google Shape;151;p15"/>
-          <p:cNvCxnSpPr/>
+      <p:sp>
+        <p:nvSpPr>
+          <p:cNvPr id="320" name="TextBox 320"/>
+          <p:cNvSpPr txBox="1"/>
           <p:nvPr/>
-        </p:nvCxnSpPr>
+        </p:nvSpPr>
         <p:spPr>
           <a:xfrm>
-            <a:off x="3903375" y="1062700"/>
-            <a:ext cx="0" cy="2765700"/>
+            <a:off x="1072000" y="3900000"/>
+            <a:ext cx="7000000" cy="900000"/>
           </a:xfrm>
-          <a:prstGeom prst="straightConnector1">
-            <a:avLst/>
+          <a:prstGeom prst="roundRect">
+            <a:avLst>
+              <a:gd name="adj" fmla="val 8000"/>
+            </a:avLst>
           </a:prstGeom>
           <a:noFill/>
-          <a:ln w="9525" cap="flat" cmpd="sng">
-            <a:solidFill>
-              <a:schemeClr val="dk2"/>
-            </a:solidFill>
-            <a:prstDash val="solid"/>
-            <a:round/>
-            <a:headEnd type="none" w="med" len="med"/>
-            <a:tailEnd type="none" w="med" len="med"/>
+          <a:ln>
+            <a:noFill/>
           </a:ln>
         </p:spPr>
-      </p:cxnSp>
-      <p:cxnSp>
-        <p:nvCxnSpPr>
-          <p:cNvPr id="152" name="Google Shape;152;p15"/>
-          <p:cNvCxnSpPr/>
-          <p:nvPr/>
-        </p:nvCxnSpPr>
-        <p:spPr>
-          <a:xfrm rot="10800000">
-            <a:off x="-50" y="3828450"/>
-            <a:ext cx="9175800" cy="35700"/>
-          </a:xfrm>
-          <a:prstGeom prst="straightConnector1">
-            <a:avLst/>
-          </a:prstGeom>
-          <a:noFill/>
-          <a:ln w="9525" cap="flat" cmpd="sng">
-            <a:solidFill>
-              <a:schemeClr val="dk2"/>
-            </a:solidFill>
-            <a:prstDash val="solid"/>
-            <a:round/>
-            <a:headEnd type="none" w="med" len="med"/>
-            <a:tailEnd type="none" w="med" len="med"/>
-          </a:ln>
-        </p:spPr>
-      </p:cxnSp>
+        <p:txBody>
+          <a:bodyPr spcFirstLastPara="1" wrap="square" lIns="91425" tIns="45700" rIns="91425" bIns="45700" anchor="t" anchorCtr="0">
+            <a:noAutofit/>
+          </a:bodyPr>
+          <a:lstStyle/>
+          <a:p>
+            <a:pPr marL="0" lvl="0" indent="0" algn="ctr" rtl="0">
+              <a:lnSpc>
+                <a:spcPct val="115000"/>
+              </a:lnSpc>
+              <a:spcBef>
+                <a:spcPts val="0"/>
+              </a:spcBef>
+              <a:spcAft>
+                <a:spcPts val="500"/>
+              </a:spcAft>
+              <a:buNone/>
+            </a:pPr>
+            <a:r>
+              <a:rPr lang="en-GB" sz="1300" dirty="0">
+                <a:solidFill>
+                  <a:schemeClr val="lt1"/>
+                </a:solidFill>
+              </a:rPr>
+              <a:t>Lemmatise, not stem — real words downstream</a:t>
+            </a:r>
+            <a:endParaRPr sz="1300">
+              <a:solidFill>
+                <a:schemeClr val="lt1"/>
+              </a:solidFill>
+            </a:endParaRPr>
+          </a:p>
+          <a:p>
+            <a:pPr marL="0" lvl="0" indent="0" algn="ctr" rtl="0">
+              <a:lnSpc>
+                <a:spcPct val="115000"/>
+              </a:lnSpc>
+              <a:spcBef>
+                <a:spcPts val="0"/>
+              </a:spcBef>
+              <a:spcAft>
+                <a:spcPts val="500"/>
+              </a:spcAft>
+              <a:buNone/>
+            </a:pPr>
+            <a:r>
+              <a:rPr lang="en-GB" sz="1300" dirty="0">
+                <a:solidFill>
+                  <a:schemeClr val="lt1"/>
+                </a:solidFill>
+              </a:rPr>
+              <a:t>Two text versions kept: cleaned for our models, raw for DistilBERT</a:t>
+            </a:r>
+            <a:endParaRPr sz="1300">
+              <a:solidFill>
+                <a:schemeClr val="lt1"/>
+              </a:solidFill>
+            </a:endParaRPr>
+          </a:p>
+        </p:txBody>
+      </p:sp>
     </p:spTree>
   </p:cSld>
   <p:clrMapOvr>
@@ -13708,7 +14732,7 @@
             </a:pPr>
             <a:r>
               <a:rPr lang="en-GB"/>
-              <a:t>Topic Modelling (Supervised)</a:t>
+              <a:t>Text Classification (Supervised)</a:t>
             </a:r>
             <a:endParaRPr/>
           </a:p>
@@ -14758,7 +15782,7 @@
   <p:cSld>
     <p:spTree>
       <p:nvGrpSpPr>
-        <p:cNvPr id="1" name="Shape 196"/>
+        <p:cNvPr id="1" name="Shape 508"/>
         <p:cNvGrpSpPr/>
         <p:nvPr/>
       </p:nvGrpSpPr>
@@ -14772,7 +15796,7 @@
       </p:grpSpPr>
       <p:sp>
         <p:nvSpPr>
-          <p:cNvPr id="197" name="Google Shape;197;p21"/>
+          <p:cNvPr id="509" name="Title 509"/>
           <p:cNvSpPr txBox="1">
             <a:spLocks noGrp="1"/>
           </p:cNvSpPr>
@@ -14806,537 +15830,906 @@
             </a:pPr>
             <a:r>
               <a:rPr lang="en-GB"/>
-              <a:t>Deep Learning Continued</a:t>
+              <a:t>Model Comparison — All Five Classifiers</a:t>
             </a:r>
             <a:endParaRPr/>
           </a:p>
         </p:txBody>
       </p:sp>
-      <p:sp>
-        <p:nvSpPr>
-          <p:cNvPr id="198" name="Google Shape;198;p21"/>
-          <p:cNvSpPr txBox="1">
-            <a:spLocks noGrp="1"/>
-          </p:cNvSpPr>
-          <p:nvPr>
-            <p:ph type="body" idx="1"/>
-          </p:nvPr>
-        </p:nvSpPr>
-        <p:spPr>
-          <a:xfrm>
-            <a:off x="104075" y="1830900"/>
-            <a:ext cx="2751600" cy="3153900"/>
-          </a:xfrm>
-          <a:prstGeom prst="rect">
-            <a:avLst/>
-          </a:prstGeom>
-        </p:spPr>
-        <p:txBody>
-          <a:bodyPr spcFirstLastPara="1" wrap="square" lIns="91425" tIns="91425" rIns="91425" bIns="91425" anchor="t" anchorCtr="0">
-            <a:normAutofit/>
-          </a:bodyPr>
-          <a:lstStyle/>
-          <a:p>
-            <a:pPr marL="0" lvl="0" indent="0" algn="l" rtl="0">
-              <a:spcBef>
-                <a:spcPts val="0"/>
-              </a:spcBef>
-              <a:spcAft>
-                <a:spcPts val="0"/>
-              </a:spcAft>
-              <a:buNone/>
-            </a:pPr>
-            <a:r>
-              <a:rPr lang="en-GB" sz="1200">
-                <a:latin typeface="Arial"/>
-                <a:ea typeface="Arial"/>
-                <a:cs typeface="Arial"/>
-                <a:sym typeface="Arial"/>
-              </a:rPr>
-              <a:t>The margin matters. </a:t>
-            </a:r>
-            <a:endParaRPr sz="1200">
-              <a:latin typeface="Arial"/>
-              <a:ea typeface="Arial"/>
-              <a:cs typeface="Arial"/>
-              <a:sym typeface="Arial"/>
-            </a:endParaRPr>
-          </a:p>
-          <a:p>
-            <a:pPr marL="0" lvl="0" indent="0" algn="l" rtl="0">
-              <a:spcBef>
-                <a:spcPts val="1200"/>
-              </a:spcBef>
-              <a:spcAft>
-                <a:spcPts val="0"/>
-              </a:spcAft>
-              <a:buNone/>
-            </a:pPr>
-            <a:r>
-              <a:rPr lang="en-GB" sz="1200">
-                <a:latin typeface="Arial"/>
-                <a:ea typeface="Arial"/>
-                <a:cs typeface="Arial"/>
-                <a:sym typeface="Arial"/>
-              </a:rPr>
-              <a:t>DistilBERT beats our Linear SVM by 0.21 percentage points </a:t>
-            </a:r>
-            <a:endParaRPr sz="1200">
-              <a:latin typeface="Arial"/>
-              <a:ea typeface="Arial"/>
-              <a:cs typeface="Arial"/>
-              <a:sym typeface="Arial"/>
-            </a:endParaRPr>
-          </a:p>
-          <a:p>
-            <a:pPr marL="0" lvl="0" indent="0" algn="l" rtl="0">
-              <a:spcBef>
-                <a:spcPts val="1200"/>
-              </a:spcBef>
-              <a:spcAft>
-                <a:spcPts val="0"/>
-              </a:spcAft>
-              <a:buNone/>
-            </a:pPr>
-            <a:r>
-              <a:rPr lang="en-GB" sz="1200">
-                <a:latin typeface="Arial"/>
-                <a:ea typeface="Arial"/>
-                <a:cs typeface="Arial"/>
-                <a:sym typeface="Arial"/>
-              </a:rPr>
-              <a:t>On a test set of 932 articles, that's a difference of two articles. </a:t>
-            </a:r>
-            <a:endParaRPr sz="1200">
-              <a:latin typeface="Arial"/>
-              <a:ea typeface="Arial"/>
-              <a:cs typeface="Arial"/>
-              <a:sym typeface="Arial"/>
-            </a:endParaRPr>
-          </a:p>
-          <a:p>
-            <a:pPr marL="0" lvl="0" indent="0" algn="l" rtl="0">
-              <a:spcBef>
-                <a:spcPts val="1200"/>
-              </a:spcBef>
-              <a:spcAft>
-                <a:spcPts val="1200"/>
-              </a:spcAft>
-              <a:buNone/>
-            </a:pPr>
-            <a:r>
-              <a:rPr lang="en-GB" sz="1200">
-                <a:latin typeface="Arial"/>
-                <a:ea typeface="Arial"/>
-                <a:cs typeface="Arial"/>
-                <a:sym typeface="Arial"/>
-              </a:rPr>
-              <a:t>The honest reading is that a 67-million-parameter transformer and a linear model over word counts are tied.</a:t>
-            </a:r>
-            <a:r>
-              <a:rPr lang="en-GB" sz="1100">
-                <a:solidFill>
-                  <a:srgbClr val="000000"/>
-                </a:solidFill>
-                <a:latin typeface="Arial"/>
-                <a:ea typeface="Arial"/>
-                <a:cs typeface="Arial"/>
-                <a:sym typeface="Arial"/>
-              </a:rPr>
-              <a:t> </a:t>
-            </a:r>
-            <a:endParaRPr sz="1100">
-              <a:solidFill>
-                <a:srgbClr val="000000"/>
-              </a:solidFill>
-              <a:latin typeface="Arial"/>
-              <a:ea typeface="Arial"/>
-              <a:cs typeface="Arial"/>
-              <a:sym typeface="Arial"/>
-            </a:endParaRPr>
-          </a:p>
-        </p:txBody>
-      </p:sp>
-      <p:sp>
-        <p:nvSpPr>
-          <p:cNvPr id="199" name="Google Shape;199;p21"/>
-          <p:cNvSpPr txBox="1"/>
+      <p:graphicFrame>
+        <p:nvGraphicFramePr>
+          <p:cNvPr id="510" name="Model comparison table"/>
+          <p:cNvGraphicFramePr>
+            <a:graphicFrameLocks noGrp="1"/>
+          </p:cNvGraphicFramePr>
           <p:nvPr/>
-        </p:nvSpPr>
-        <p:spPr>
-          <a:xfrm>
-            <a:off x="2945300" y="1527725"/>
-            <a:ext cx="2980800" cy="3518700"/>
-          </a:xfrm>
-          <a:prstGeom prst="rect">
-            <a:avLst/>
-          </a:prstGeom>
-          <a:noFill/>
-          <a:ln>
-            <a:noFill/>
-          </a:ln>
-        </p:spPr>
-        <p:txBody>
-          <a:bodyPr spcFirstLastPara="1" wrap="square" lIns="91425" tIns="91425" rIns="91425" bIns="91425" anchor="t" anchorCtr="0">
-            <a:noAutofit/>
-          </a:bodyPr>
-          <a:lstStyle/>
-          <a:p>
-            <a:pPr marL="0" lvl="0" indent="0" algn="l" rtl="0">
-              <a:spcBef>
-                <a:spcPts val="0"/>
-              </a:spcBef>
-              <a:spcAft>
-                <a:spcPts val="0"/>
-              </a:spcAft>
-              <a:buNone/>
-            </a:pPr>
-            <a:r>
-              <a:rPr lang="en-GB" sz="1200">
-                <a:solidFill>
-                  <a:schemeClr val="lt1"/>
-                </a:solidFill>
-              </a:rPr>
-              <a:t>Our two deep learning models are at opposite ends?</a:t>
-            </a:r>
-            <a:endParaRPr sz="1200">
-              <a:solidFill>
-                <a:schemeClr val="lt1"/>
-              </a:solidFill>
-            </a:endParaRPr>
-          </a:p>
-          <a:p>
-            <a:pPr marL="0" lvl="0" indent="0" algn="l" rtl="0">
-              <a:spcBef>
-                <a:spcPts val="0"/>
-              </a:spcBef>
-              <a:spcAft>
-                <a:spcPts val="0"/>
-              </a:spcAft>
-              <a:buNone/>
-            </a:pPr>
-            <a:endParaRPr sz="1200">
-              <a:solidFill>
-                <a:schemeClr val="lt1"/>
-              </a:solidFill>
-            </a:endParaRPr>
-          </a:p>
-          <a:p>
-            <a:pPr marL="0" lvl="0" indent="0" algn="l" rtl="0">
-              <a:spcBef>
-                <a:spcPts val="0"/>
-              </a:spcBef>
-              <a:spcAft>
-                <a:spcPts val="0"/>
-              </a:spcAft>
-              <a:buNone/>
-            </a:pPr>
-            <a:r>
-              <a:rPr lang="en-GB" sz="1200">
-                <a:solidFill>
-                  <a:schemeClr val="lt1"/>
-                </a:solidFill>
-              </a:rPr>
-              <a:t>DistilBERT at 97.2%, the LSTM at 81.6%. </a:t>
-            </a:r>
-            <a:endParaRPr sz="1200">
-              <a:solidFill>
-                <a:schemeClr val="lt1"/>
-              </a:solidFill>
-            </a:endParaRPr>
-          </a:p>
-          <a:p>
-            <a:pPr marL="0" lvl="0" indent="0" algn="l" rtl="0">
-              <a:spcBef>
-                <a:spcPts val="0"/>
-              </a:spcBef>
-              <a:spcAft>
-                <a:spcPts val="0"/>
-              </a:spcAft>
-              <a:buNone/>
-            </a:pPr>
-            <a:endParaRPr sz="1200">
-              <a:solidFill>
-                <a:schemeClr val="lt1"/>
-              </a:solidFill>
-            </a:endParaRPr>
-          </a:p>
-          <a:p>
-            <a:pPr marL="0" lvl="0" indent="0" algn="l" rtl="0">
-              <a:spcBef>
-                <a:spcPts val="0"/>
-              </a:spcBef>
-              <a:spcAft>
-                <a:spcPts val="0"/>
-              </a:spcAft>
-              <a:buNone/>
-            </a:pPr>
-            <a:r>
-              <a:rPr lang="en-GB" sz="1200">
-                <a:solidFill>
-                  <a:schemeClr val="lt1"/>
-                </a:solidFill>
-              </a:rPr>
-              <a:t>Meanwhile DistilBERT and a bag-of-words SVM differ by 0.2. </a:t>
-            </a:r>
-            <a:endParaRPr sz="1200">
-              <a:solidFill>
-                <a:schemeClr val="lt1"/>
-              </a:solidFill>
-            </a:endParaRPr>
-          </a:p>
-          <a:p>
-            <a:pPr marL="0" lvl="0" indent="0" algn="l" rtl="0">
-              <a:spcBef>
-                <a:spcPts val="0"/>
-              </a:spcBef>
-              <a:spcAft>
-                <a:spcPts val="0"/>
-              </a:spcAft>
-              <a:buNone/>
-            </a:pPr>
-            <a:endParaRPr sz="1200">
-              <a:solidFill>
-                <a:schemeClr val="lt1"/>
-              </a:solidFill>
-            </a:endParaRPr>
-          </a:p>
-          <a:p>
-            <a:pPr marL="0" lvl="0" indent="0" algn="l" rtl="0">
-              <a:spcBef>
-                <a:spcPts val="0"/>
-              </a:spcBef>
-              <a:spcAft>
-                <a:spcPts val="0"/>
-              </a:spcAft>
-              <a:buNone/>
-            </a:pPr>
-            <a:endParaRPr sz="1200">
-              <a:solidFill>
-                <a:schemeClr val="lt1"/>
-              </a:solidFill>
-            </a:endParaRPr>
-          </a:p>
-          <a:p>
-            <a:pPr marL="0" lvl="0" indent="0" algn="l" rtl="0">
-              <a:spcBef>
-                <a:spcPts val="0"/>
-              </a:spcBef>
-              <a:spcAft>
-                <a:spcPts val="0"/>
-              </a:spcAft>
-              <a:buNone/>
-            </a:pPr>
-            <a:r>
-              <a:rPr lang="en-GB" sz="1200">
-                <a:solidFill>
-                  <a:schemeClr val="lt1"/>
-                </a:solidFill>
-              </a:rPr>
-              <a:t>DistilBERT starts from representations learned on billions of words and only has to learn the mapping onto five labels. </a:t>
-            </a:r>
-            <a:endParaRPr sz="1200">
-              <a:solidFill>
-                <a:schemeClr val="lt1"/>
-              </a:solidFill>
-            </a:endParaRPr>
-          </a:p>
-          <a:p>
-            <a:pPr marL="0" lvl="0" indent="0" algn="l" rtl="0">
-              <a:spcBef>
-                <a:spcPts val="0"/>
-              </a:spcBef>
-              <a:spcAft>
-                <a:spcPts val="0"/>
-              </a:spcAft>
-              <a:buNone/>
-            </a:pPr>
-            <a:endParaRPr sz="1200">
-              <a:solidFill>
-                <a:schemeClr val="lt1"/>
-              </a:solidFill>
-            </a:endParaRPr>
-          </a:p>
-          <a:p>
-            <a:pPr marL="0" lvl="0" indent="0" algn="l" rtl="0">
-              <a:spcBef>
-                <a:spcPts val="0"/>
-              </a:spcBef>
-              <a:spcAft>
-                <a:spcPts val="0"/>
-              </a:spcAft>
-              <a:buNone/>
-            </a:pPr>
-            <a:r>
-              <a:rPr lang="en-GB" sz="1200">
-                <a:solidFill>
-                  <a:schemeClr val="lt1"/>
-                </a:solidFill>
-              </a:rPr>
-              <a:t>The LSTM starts from random noise and has to learn what words mean and how to classify </a:t>
-            </a:r>
-            <a:endParaRPr sz="1200">
-              <a:solidFill>
-                <a:schemeClr val="lt1"/>
-              </a:solidFill>
-            </a:endParaRPr>
-          </a:p>
-        </p:txBody>
-      </p:sp>
-      <p:sp>
-        <p:nvSpPr>
-          <p:cNvPr id="200" name="Google Shape;200;p21"/>
-          <p:cNvSpPr txBox="1"/>
-          <p:nvPr/>
-        </p:nvSpPr>
-        <p:spPr>
-          <a:xfrm>
-            <a:off x="6015700" y="1824700"/>
-            <a:ext cx="2930400" cy="3115200"/>
-          </a:xfrm>
-          <a:prstGeom prst="rect">
-            <a:avLst/>
-          </a:prstGeom>
-          <a:noFill/>
-          <a:ln>
-            <a:noFill/>
-          </a:ln>
-        </p:spPr>
-        <p:txBody>
-          <a:bodyPr spcFirstLastPara="1" wrap="square" lIns="91425" tIns="91425" rIns="91425" bIns="91425" anchor="t" anchorCtr="0">
-            <a:noAutofit/>
-          </a:bodyPr>
-          <a:lstStyle/>
-          <a:p>
-            <a:pPr marL="0" lvl="0" indent="0" algn="l" rtl="0">
-              <a:spcBef>
-                <a:spcPts val="0"/>
-              </a:spcBef>
-              <a:spcAft>
-                <a:spcPts val="0"/>
-              </a:spcAft>
-              <a:buNone/>
-            </a:pPr>
-            <a:r>
-              <a:rPr lang="en-GB" sz="1200">
-                <a:solidFill>
-                  <a:schemeClr val="lt1"/>
-                </a:solidFill>
-                <a:latin typeface="Lato"/>
-                <a:ea typeface="Lato"/>
-                <a:cs typeface="Lato"/>
-                <a:sym typeface="Lato"/>
-              </a:rPr>
-              <a:t>Transformers </a:t>
-            </a:r>
-            <a:r>
-              <a:rPr lang="en-GB" sz="1200">
-                <a:solidFill>
-                  <a:schemeClr val="lt1"/>
-                </a:solidFill>
-              </a:rPr>
-              <a:t>advantage is understanding context and word sense </a:t>
-            </a:r>
-            <a:endParaRPr sz="1200">
-              <a:solidFill>
-                <a:schemeClr val="lt1"/>
-              </a:solidFill>
-            </a:endParaRPr>
-          </a:p>
-          <a:p>
-            <a:pPr marL="0" lvl="0" indent="0" algn="l" rtl="0">
-              <a:spcBef>
-                <a:spcPts val="0"/>
-              </a:spcBef>
-              <a:spcAft>
-                <a:spcPts val="0"/>
-              </a:spcAft>
-              <a:buNone/>
-            </a:pPr>
-            <a:endParaRPr sz="1200">
-              <a:solidFill>
-                <a:schemeClr val="lt1"/>
-              </a:solidFill>
-            </a:endParaRPr>
-          </a:p>
-          <a:p>
-            <a:pPr marL="0" lvl="0" indent="0" algn="l" rtl="0">
-              <a:spcBef>
-                <a:spcPts val="0"/>
-              </a:spcBef>
-              <a:spcAft>
-                <a:spcPts val="0"/>
-              </a:spcAft>
-              <a:buNone/>
-            </a:pPr>
-            <a:r>
-              <a:rPr lang="en-GB" sz="1200">
-                <a:solidFill>
-                  <a:schemeClr val="lt1"/>
-                </a:solidFill>
-              </a:rPr>
-              <a:t>BBC categories are so lexically distinct that the word 'shares' or the word 'scored' basically settles the answer on its own </a:t>
-            </a:r>
-            <a:endParaRPr sz="1200">
-              <a:solidFill>
-                <a:schemeClr val="lt1"/>
-              </a:solidFill>
-            </a:endParaRPr>
-          </a:p>
-        </p:txBody>
-      </p:sp>
-      <p:cxnSp>
-        <p:nvCxnSpPr>
-          <p:cNvPr id="201" name="Google Shape;201;p21"/>
-          <p:cNvCxnSpPr/>
-          <p:nvPr/>
-        </p:nvCxnSpPr>
-        <p:spPr>
-          <a:xfrm>
-            <a:off x="2850000" y="1690500"/>
-            <a:ext cx="5700" cy="3434700"/>
-          </a:xfrm>
-          <a:prstGeom prst="straightConnector1">
-            <a:avLst/>
-          </a:prstGeom>
-          <a:noFill/>
-          <a:ln w="9525" cap="flat" cmpd="sng">
-            <a:solidFill>
-              <a:schemeClr val="dk2"/>
-            </a:solidFill>
-            <a:prstDash val="solid"/>
-            <a:round/>
-            <a:headEnd type="none" w="med" len="med"/>
-            <a:tailEnd type="none" w="med" len="med"/>
-          </a:ln>
-        </p:spPr>
-      </p:cxnSp>
-      <p:cxnSp>
-        <p:nvCxnSpPr>
-          <p:cNvPr id="202" name="Google Shape;202;p21"/>
-          <p:cNvCxnSpPr/>
-          <p:nvPr/>
-        </p:nvCxnSpPr>
-        <p:spPr>
-          <a:xfrm>
-            <a:off x="5882350" y="1708800"/>
-            <a:ext cx="5700" cy="3434700"/>
-          </a:xfrm>
-          <a:prstGeom prst="straightConnector1">
-            <a:avLst/>
-          </a:prstGeom>
-          <a:noFill/>
-          <a:ln w="9525" cap="flat" cmpd="sng">
-            <a:solidFill>
-              <a:schemeClr val="dk2"/>
-            </a:solidFill>
-            <a:prstDash val="solid"/>
-            <a:round/>
-            <a:headEnd type="none" w="med" len="med"/>
-            <a:tailEnd type="none" w="med" len="med"/>
-          </a:ln>
-        </p:spPr>
-      </p:cxnSp>
+        </p:nvGraphicFramePr>
+        <p:xfrm>
+          <a:off x="822000" y="1560000"/>
+          <a:ext cx="7500000" cy="3040000"/>
+        </p:xfrm>
+        <a:graphic>
+          <a:graphicData uri="http://schemas.openxmlformats.org/drawingml/2006/table">
+            <a:tbl>
+              <a:tblPr firstRow="1" bandRow="0"/>
+              <a:tblGrid>
+                <a:gridCol w="2800000"/>
+                <a:gridCol w="1900000"/>
+                <a:gridCol w="1400000"/>
+                <a:gridCol w="1400000"/>
+              </a:tblGrid>
+              <a:tr h="460000">
+                <a:tc>
+                  <a:txBody>
+                    <a:bodyPr/>
+                    <a:lstStyle/>
+                    <a:p>
+                      <a:pPr marL="0" lvl="0" indent="0" algn="l" rtl="0">
+                        <a:buNone/>
+                      </a:pPr>
+                      <a:r>
+                        <a:rPr lang="en-GB" sz="1300" b="1" dirty="0">
+                          <a:solidFill>
+                            <a:schemeClr val="lt1"/>
+                          </a:solidFill>
+                        </a:rPr>
+                        <a:t>Model</a:t>
+                      </a:r>
+                      <a:endParaRPr sz="1300" b="1">
+                        <a:solidFill>
+                          <a:schemeClr val="lt1"/>
+                        </a:solidFill>
+                      </a:endParaRPr>
+                    </a:p>
+                  </a:txBody>
+                  <a:tcPr marL="91440" marR="91440" marT="45720" marB="45720" anchor="ctr">
+                    <a:lnB w="9525" cap="flat" cmpd="sng">
+                      <a:solidFill>
+                        <a:schemeClr val="lt1">
+                          <a:alpha val="35000"/>
+                        </a:schemeClr>
+                      </a:solidFill>
+                      <a:prstDash val="solid"/>
+                    </a:lnB>
+                    <a:solidFill>
+                      <a:schemeClr val="lt2">
+                        <a:alpha val="25000"/>
+                      </a:schemeClr>
+                    </a:solidFill>
+                  </a:tcPr>
+                </a:tc>
+                <a:tc>
+                  <a:txBody>
+                    <a:bodyPr/>
+                    <a:lstStyle/>
+                    <a:p>
+                      <a:pPr marL="0" lvl="0" indent="0" algn="l" rtl="0">
+                        <a:buNone/>
+                      </a:pPr>
+                      <a:r>
+                        <a:rPr lang="en-GB" sz="1300" b="1" dirty="0">
+                          <a:solidFill>
+                            <a:schemeClr val="lt1"/>
+                          </a:solidFill>
+                        </a:rPr>
+                        <a:t>Type</a:t>
+                      </a:r>
+                      <a:endParaRPr sz="1300" b="1">
+                        <a:solidFill>
+                          <a:schemeClr val="lt1"/>
+                        </a:solidFill>
+                      </a:endParaRPr>
+                    </a:p>
+                  </a:txBody>
+                  <a:tcPr marL="91440" marR="91440" marT="45720" marB="45720" anchor="ctr">
+                    <a:lnB w="9525" cap="flat" cmpd="sng">
+                      <a:solidFill>
+                        <a:schemeClr val="lt1">
+                          <a:alpha val="35000"/>
+                        </a:schemeClr>
+                      </a:solidFill>
+                      <a:prstDash val="solid"/>
+                    </a:lnB>
+                    <a:solidFill>
+                      <a:schemeClr val="lt2">
+                        <a:alpha val="25000"/>
+                      </a:schemeClr>
+                    </a:solidFill>
+                  </a:tcPr>
+                </a:tc>
+                <a:tc>
+                  <a:txBody>
+                    <a:bodyPr/>
+                    <a:lstStyle/>
+                    <a:p>
+                      <a:pPr marL="0" lvl="0" indent="0" algn="r" rtl="0">
+                        <a:buNone/>
+                      </a:pPr>
+                      <a:r>
+                        <a:rPr lang="en-GB" sz="1300" b="1" dirty="0">
+                          <a:solidFill>
+                            <a:schemeClr val="lt1"/>
+                          </a:solidFill>
+                        </a:rPr>
+                        <a:t>Accuracy</a:t>
+                      </a:r>
+                      <a:endParaRPr sz="1300" b="1">
+                        <a:solidFill>
+                          <a:schemeClr val="lt1"/>
+                        </a:solidFill>
+                      </a:endParaRPr>
+                    </a:p>
+                  </a:txBody>
+                  <a:tcPr marL="91440" marR="91440" marT="45720" marB="45720" anchor="ctr">
+                    <a:lnB w="9525" cap="flat" cmpd="sng">
+                      <a:solidFill>
+                        <a:schemeClr val="lt1">
+                          <a:alpha val="35000"/>
+                        </a:schemeClr>
+                      </a:solidFill>
+                      <a:prstDash val="solid"/>
+                    </a:lnB>
+                    <a:solidFill>
+                      <a:schemeClr val="lt2">
+                        <a:alpha val="25000"/>
+                      </a:schemeClr>
+                    </a:solidFill>
+                  </a:tcPr>
+                </a:tc>
+                <a:tc>
+                  <a:txBody>
+                    <a:bodyPr/>
+                    <a:lstStyle/>
+                    <a:p>
+                      <a:pPr marL="0" lvl="0" indent="0" algn="r" rtl="0">
+                        <a:buNone/>
+                      </a:pPr>
+                      <a:r>
+                        <a:rPr lang="en-GB" sz="1300" b="1" dirty="0">
+                          <a:solidFill>
+                            <a:schemeClr val="lt1"/>
+                          </a:solidFill>
+                        </a:rPr>
+                        <a:t>Macro F1</a:t>
+                      </a:r>
+                      <a:endParaRPr sz="1300" b="1">
+                        <a:solidFill>
+                          <a:schemeClr val="lt1"/>
+                        </a:solidFill>
+                      </a:endParaRPr>
+                    </a:p>
+                  </a:txBody>
+                  <a:tcPr marL="91440" marR="91440" marT="45720" marB="45720" anchor="ctr">
+                    <a:lnB w="9525" cap="flat" cmpd="sng">
+                      <a:solidFill>
+                        <a:schemeClr val="lt1">
+                          <a:alpha val="35000"/>
+                        </a:schemeClr>
+                      </a:solidFill>
+                      <a:prstDash val="solid"/>
+                    </a:lnB>
+                    <a:solidFill>
+                      <a:schemeClr val="lt2">
+                        <a:alpha val="25000"/>
+                      </a:schemeClr>
+                    </a:solidFill>
+                  </a:tcPr>
+                </a:tc>
+              </a:tr>
+              <a:tr h="430000">
+                <a:tc>
+                  <a:txBody>
+                    <a:bodyPr/>
+                    <a:lstStyle/>
+                    <a:p>
+                      <a:pPr marL="0" lvl="0" indent="0" algn="l" rtl="0">
+                        <a:buNone/>
+                      </a:pPr>
+                      <a:r>
+                        <a:rPr lang="en-GB" sz="1300" b="1" dirty="0">
+                          <a:solidFill>
+                            <a:schemeClr val="lt1"/>
+                          </a:solidFill>
+                        </a:rPr>
+                        <a:t>DistilBERT (fine-tuned)</a:t>
+                      </a:r>
+                      <a:endParaRPr sz="1300" b="1">
+                        <a:solidFill>
+                          <a:schemeClr val="lt1"/>
+                        </a:solidFill>
+                      </a:endParaRPr>
+                    </a:p>
+                  </a:txBody>
+                  <a:tcPr marL="91440" marR="91440" marT="45720" marB="45720" anchor="ctr">
+                    <a:lnB w="9525" cap="flat" cmpd="sng">
+                      <a:solidFill>
+                        <a:schemeClr val="lt1">
+                          <a:alpha val="35000"/>
+                        </a:schemeClr>
+                      </a:solidFill>
+                      <a:prstDash val="solid"/>
+                    </a:lnB>
+                    <a:noFill/>
+                  </a:tcPr>
+                </a:tc>
+                <a:tc>
+                  <a:txBody>
+                    <a:bodyPr/>
+                    <a:lstStyle/>
+                    <a:p>
+                      <a:pPr marL="0" lvl="0" indent="0" algn="l" rtl="0">
+                        <a:buNone/>
+                      </a:pPr>
+                      <a:r>
+                        <a:rPr lang="en-GB" sz="1300" dirty="0">
+                          <a:solidFill>
+                            <a:schemeClr val="lt1"/>
+                          </a:solidFill>
+                        </a:rPr>
+                        <a:t>Deep Learning</a:t>
+                      </a:r>
+                      <a:endParaRPr sz="1300">
+                        <a:solidFill>
+                          <a:schemeClr val="lt1"/>
+                        </a:solidFill>
+                      </a:endParaRPr>
+                    </a:p>
+                  </a:txBody>
+                  <a:tcPr marL="91440" marR="91440" marT="45720" marB="45720" anchor="ctr">
+                    <a:lnB w="9525" cap="flat" cmpd="sng">
+                      <a:solidFill>
+                        <a:schemeClr val="lt1">
+                          <a:alpha val="35000"/>
+                        </a:schemeClr>
+                      </a:solidFill>
+                      <a:prstDash val="solid"/>
+                    </a:lnB>
+                    <a:noFill/>
+                  </a:tcPr>
+                </a:tc>
+                <a:tc>
+                  <a:txBody>
+                    <a:bodyPr/>
+                    <a:lstStyle/>
+                    <a:p>
+                      <a:pPr marL="0" lvl="0" indent="0" algn="r" rtl="0">
+                        <a:buNone/>
+                      </a:pPr>
+                      <a:r>
+                        <a:rPr lang="en-GB" sz="1300" dirty="0">
+                          <a:solidFill>
+                            <a:schemeClr val="lt1"/>
+                          </a:solidFill>
+                        </a:rPr>
+                        <a:t>97.21%</a:t>
+                      </a:r>
+                      <a:endParaRPr sz="1300">
+                        <a:solidFill>
+                          <a:schemeClr val="lt1"/>
+                        </a:solidFill>
+                      </a:endParaRPr>
+                    </a:p>
+                  </a:txBody>
+                  <a:tcPr marL="91440" marR="91440" marT="45720" marB="45720" anchor="ctr">
+                    <a:lnB w="9525" cap="flat" cmpd="sng">
+                      <a:solidFill>
+                        <a:schemeClr val="lt1">
+                          <a:alpha val="35000"/>
+                        </a:schemeClr>
+                      </a:solidFill>
+                      <a:prstDash val="solid"/>
+                    </a:lnB>
+                    <a:noFill/>
+                  </a:tcPr>
+                </a:tc>
+                <a:tc>
+                  <a:txBody>
+                    <a:bodyPr/>
+                    <a:lstStyle/>
+                    <a:p>
+                      <a:pPr marL="0" lvl="0" indent="0" algn="r" rtl="0">
+                        <a:buNone/>
+                      </a:pPr>
+                      <a:r>
+                        <a:rPr lang="en-GB" sz="1300" dirty="0">
+                          <a:solidFill>
+                            <a:schemeClr val="lt1"/>
+                          </a:solidFill>
+                        </a:rPr>
+                        <a:t>0.971</a:t>
+                      </a:r>
+                      <a:endParaRPr sz="1300">
+                        <a:solidFill>
+                          <a:schemeClr val="lt1"/>
+                        </a:solidFill>
+                      </a:endParaRPr>
+                    </a:p>
+                  </a:txBody>
+                  <a:tcPr marL="91440" marR="91440" marT="45720" marB="45720" anchor="ctr">
+                    <a:lnB w="9525" cap="flat" cmpd="sng">
+                      <a:solidFill>
+                        <a:schemeClr val="lt1">
+                          <a:alpha val="35000"/>
+                        </a:schemeClr>
+                      </a:solidFill>
+                      <a:prstDash val="solid"/>
+                    </a:lnB>
+                    <a:noFill/>
+                  </a:tcPr>
+                </a:tc>
+              </a:tr>
+              <a:tr h="430000">
+                <a:tc>
+                  <a:txBody>
+                    <a:bodyPr/>
+                    <a:lstStyle/>
+                    <a:p>
+                      <a:pPr marL="0" lvl="0" indent="0" algn="l" rtl="0">
+                        <a:buNone/>
+                      </a:pPr>
+                      <a:r>
+                        <a:rPr lang="en-GB" sz="1300" dirty="0">
+                          <a:solidFill>
+                            <a:schemeClr val="lt1"/>
+                          </a:solidFill>
+                        </a:rPr>
+                        <a:t>Linear SVM</a:t>
+                      </a:r>
+                      <a:endParaRPr sz="1300">
+                        <a:solidFill>
+                          <a:schemeClr val="lt1"/>
+                        </a:solidFill>
+                      </a:endParaRPr>
+                    </a:p>
+                  </a:txBody>
+                  <a:tcPr marL="91440" marR="91440" marT="45720" marB="45720" anchor="ctr">
+                    <a:lnB w="9525" cap="flat" cmpd="sng">
+                      <a:solidFill>
+                        <a:schemeClr val="lt1">
+                          <a:alpha val="35000"/>
+                        </a:schemeClr>
+                      </a:solidFill>
+                      <a:prstDash val="solid"/>
+                    </a:lnB>
+                    <a:noFill/>
+                  </a:tcPr>
+                </a:tc>
+                <a:tc>
+                  <a:txBody>
+                    <a:bodyPr/>
+                    <a:lstStyle/>
+                    <a:p>
+                      <a:pPr marL="0" lvl="0" indent="0" algn="l" rtl="0">
+                        <a:buNone/>
+                      </a:pPr>
+                      <a:r>
+                        <a:rPr lang="en-GB" sz="1300" dirty="0">
+                          <a:solidFill>
+                            <a:schemeClr val="lt1"/>
+                          </a:solidFill>
+                        </a:rPr>
+                        <a:t>Traditional ML</a:t>
+                      </a:r>
+                      <a:endParaRPr sz="1300">
+                        <a:solidFill>
+                          <a:schemeClr val="lt1"/>
+                        </a:solidFill>
+                      </a:endParaRPr>
+                    </a:p>
+                  </a:txBody>
+                  <a:tcPr marL="91440" marR="91440" marT="45720" marB="45720" anchor="ctr">
+                    <a:lnB w="9525" cap="flat" cmpd="sng">
+                      <a:solidFill>
+                        <a:schemeClr val="lt1">
+                          <a:alpha val="35000"/>
+                        </a:schemeClr>
+                      </a:solidFill>
+                      <a:prstDash val="solid"/>
+                    </a:lnB>
+                    <a:noFill/>
+                  </a:tcPr>
+                </a:tc>
+                <a:tc>
+                  <a:txBody>
+                    <a:bodyPr/>
+                    <a:lstStyle/>
+                    <a:p>
+                      <a:pPr marL="0" lvl="0" indent="0" algn="r" rtl="0">
+                        <a:buNone/>
+                      </a:pPr>
+                      <a:r>
+                        <a:rPr lang="en-GB" sz="1300" dirty="0">
+                          <a:solidFill>
+                            <a:schemeClr val="lt1"/>
+                          </a:solidFill>
+                        </a:rPr>
+                        <a:t>97.00%</a:t>
+                      </a:r>
+                      <a:endParaRPr sz="1300">
+                        <a:solidFill>
+                          <a:schemeClr val="lt1"/>
+                        </a:solidFill>
+                      </a:endParaRPr>
+                    </a:p>
+                  </a:txBody>
+                  <a:tcPr marL="91440" marR="91440" marT="45720" marB="45720" anchor="ctr">
+                    <a:lnB w="9525" cap="flat" cmpd="sng">
+                      <a:solidFill>
+                        <a:schemeClr val="lt1">
+                          <a:alpha val="35000"/>
+                        </a:schemeClr>
+                      </a:solidFill>
+                      <a:prstDash val="solid"/>
+                    </a:lnB>
+                    <a:noFill/>
+                  </a:tcPr>
+                </a:tc>
+                <a:tc>
+                  <a:txBody>
+                    <a:bodyPr/>
+                    <a:lstStyle/>
+                    <a:p>
+                      <a:pPr marL="0" lvl="0" indent="0" algn="r" rtl="0">
+                        <a:buNone/>
+                      </a:pPr>
+                      <a:r>
+                        <a:rPr lang="en-GB" sz="1300" dirty="0">
+                          <a:solidFill>
+                            <a:schemeClr val="lt1"/>
+                          </a:solidFill>
+                        </a:rPr>
+                        <a:t>0.969</a:t>
+                      </a:r>
+                      <a:endParaRPr sz="1300">
+                        <a:solidFill>
+                          <a:schemeClr val="lt1"/>
+                        </a:solidFill>
+                      </a:endParaRPr>
+                    </a:p>
+                  </a:txBody>
+                  <a:tcPr marL="91440" marR="91440" marT="45720" marB="45720" anchor="ctr">
+                    <a:lnB w="9525" cap="flat" cmpd="sng">
+                      <a:solidFill>
+                        <a:schemeClr val="lt1">
+                          <a:alpha val="35000"/>
+                        </a:schemeClr>
+                      </a:solidFill>
+                      <a:prstDash val="solid"/>
+                    </a:lnB>
+                    <a:noFill/>
+                  </a:tcPr>
+                </a:tc>
+              </a:tr>
+              <a:tr h="430000">
+                <a:tc>
+                  <a:txBody>
+                    <a:bodyPr/>
+                    <a:lstStyle/>
+                    <a:p>
+                      <a:pPr marL="0" lvl="0" indent="0" algn="l" rtl="0">
+                        <a:buNone/>
+                      </a:pPr>
+                      <a:r>
+                        <a:rPr lang="en-GB" sz="1300" dirty="0">
+                          <a:solidFill>
+                            <a:schemeClr val="lt1"/>
+                          </a:solidFill>
+                        </a:rPr>
+                        <a:t>Logistic Regression</a:t>
+                      </a:r>
+                      <a:endParaRPr sz="1300">
+                        <a:solidFill>
+                          <a:schemeClr val="lt1"/>
+                        </a:solidFill>
+                      </a:endParaRPr>
+                    </a:p>
+                  </a:txBody>
+                  <a:tcPr marL="91440" marR="91440" marT="45720" marB="45720" anchor="ctr">
+                    <a:lnB w="9525" cap="flat" cmpd="sng">
+                      <a:solidFill>
+                        <a:schemeClr val="lt1">
+                          <a:alpha val="35000"/>
+                        </a:schemeClr>
+                      </a:solidFill>
+                      <a:prstDash val="solid"/>
+                    </a:lnB>
+                    <a:noFill/>
+                  </a:tcPr>
+                </a:tc>
+                <a:tc>
+                  <a:txBody>
+                    <a:bodyPr/>
+                    <a:lstStyle/>
+                    <a:p>
+                      <a:pPr marL="0" lvl="0" indent="0" algn="l" rtl="0">
+                        <a:buNone/>
+                      </a:pPr>
+                      <a:r>
+                        <a:rPr lang="en-GB" sz="1300" dirty="0">
+                          <a:solidFill>
+                            <a:schemeClr val="lt1"/>
+                          </a:solidFill>
+                        </a:rPr>
+                        <a:t>Traditional ML</a:t>
+                      </a:r>
+                      <a:endParaRPr sz="1300">
+                        <a:solidFill>
+                          <a:schemeClr val="lt1"/>
+                        </a:solidFill>
+                      </a:endParaRPr>
+                    </a:p>
+                  </a:txBody>
+                  <a:tcPr marL="91440" marR="91440" marT="45720" marB="45720" anchor="ctr">
+                    <a:lnB w="9525" cap="flat" cmpd="sng">
+                      <a:solidFill>
+                        <a:schemeClr val="lt1">
+                          <a:alpha val="35000"/>
+                        </a:schemeClr>
+                      </a:solidFill>
+                      <a:prstDash val="solid"/>
+                    </a:lnB>
+                    <a:noFill/>
+                  </a:tcPr>
+                </a:tc>
+                <a:tc>
+                  <a:txBody>
+                    <a:bodyPr/>
+                    <a:lstStyle/>
+                    <a:p>
+                      <a:pPr marL="0" lvl="0" indent="0" algn="r" rtl="0">
+                        <a:buNone/>
+                      </a:pPr>
+                      <a:r>
+                        <a:rPr lang="en-GB" sz="1300" dirty="0">
+                          <a:solidFill>
+                            <a:schemeClr val="lt1"/>
+                          </a:solidFill>
+                        </a:rPr>
+                        <a:t>96.78%</a:t>
+                      </a:r>
+                      <a:endParaRPr sz="1300">
+                        <a:solidFill>
+                          <a:schemeClr val="lt1"/>
+                        </a:solidFill>
+                      </a:endParaRPr>
+                    </a:p>
+                  </a:txBody>
+                  <a:tcPr marL="91440" marR="91440" marT="45720" marB="45720" anchor="ctr">
+                    <a:lnB w="9525" cap="flat" cmpd="sng">
+                      <a:solidFill>
+                        <a:schemeClr val="lt1">
+                          <a:alpha val="35000"/>
+                        </a:schemeClr>
+                      </a:solidFill>
+                      <a:prstDash val="solid"/>
+                    </a:lnB>
+                    <a:noFill/>
+                  </a:tcPr>
+                </a:tc>
+                <a:tc>
+                  <a:txBody>
+                    <a:bodyPr/>
+                    <a:lstStyle/>
+                    <a:p>
+                      <a:pPr marL="0" lvl="0" indent="0" algn="r" rtl="0">
+                        <a:buNone/>
+                      </a:pPr>
+                      <a:r>
+                        <a:rPr lang="en-GB" sz="1300" dirty="0">
+                          <a:solidFill>
+                            <a:schemeClr val="lt1"/>
+                          </a:solidFill>
+                        </a:rPr>
+                        <a:t>0.967</a:t>
+                      </a:r>
+                      <a:endParaRPr sz="1300">
+                        <a:solidFill>
+                          <a:schemeClr val="lt1"/>
+                        </a:solidFill>
+                      </a:endParaRPr>
+                    </a:p>
+                  </a:txBody>
+                  <a:tcPr marL="91440" marR="91440" marT="45720" marB="45720" anchor="ctr">
+                    <a:lnB w="9525" cap="flat" cmpd="sng">
+                      <a:solidFill>
+                        <a:schemeClr val="lt1">
+                          <a:alpha val="35000"/>
+                        </a:schemeClr>
+                      </a:solidFill>
+                      <a:prstDash val="solid"/>
+                    </a:lnB>
+                    <a:noFill/>
+                  </a:tcPr>
+                </a:tc>
+              </a:tr>
+              <a:tr h="430000">
+                <a:tc>
+                  <a:txBody>
+                    <a:bodyPr/>
+                    <a:lstStyle/>
+                    <a:p>
+                      <a:pPr marL="0" lvl="0" indent="0" algn="l" rtl="0">
+                        <a:buNone/>
+                      </a:pPr>
+                      <a:r>
+                        <a:rPr lang="en-GB" sz="1300" dirty="0">
+                          <a:solidFill>
+                            <a:schemeClr val="lt1"/>
+                          </a:solidFill>
+                        </a:rPr>
+                        <a:t>Naive Bayes</a:t>
+                      </a:r>
+                      <a:endParaRPr sz="1300">
+                        <a:solidFill>
+                          <a:schemeClr val="lt1"/>
+                        </a:solidFill>
+                      </a:endParaRPr>
+                    </a:p>
+                  </a:txBody>
+                  <a:tcPr marL="91440" marR="91440" marT="45720" marB="45720" anchor="ctr">
+                    <a:lnB w="9525" cap="flat" cmpd="sng">
+                      <a:solidFill>
+                        <a:schemeClr val="lt1">
+                          <a:alpha val="35000"/>
+                        </a:schemeClr>
+                      </a:solidFill>
+                      <a:prstDash val="solid"/>
+                    </a:lnB>
+                    <a:noFill/>
+                  </a:tcPr>
+                </a:tc>
+                <a:tc>
+                  <a:txBody>
+                    <a:bodyPr/>
+                    <a:lstStyle/>
+                    <a:p>
+                      <a:pPr marL="0" lvl="0" indent="0" algn="l" rtl="0">
+                        <a:buNone/>
+                      </a:pPr>
+                      <a:r>
+                        <a:rPr lang="en-GB" sz="1300" dirty="0">
+                          <a:solidFill>
+                            <a:schemeClr val="lt1"/>
+                          </a:solidFill>
+                        </a:rPr>
+                        <a:t>Traditional ML</a:t>
+                      </a:r>
+                      <a:endParaRPr sz="1300">
+                        <a:solidFill>
+                          <a:schemeClr val="lt1"/>
+                        </a:solidFill>
+                      </a:endParaRPr>
+                    </a:p>
+                  </a:txBody>
+                  <a:tcPr marL="91440" marR="91440" marT="45720" marB="45720" anchor="ctr">
+                    <a:lnB w="9525" cap="flat" cmpd="sng">
+                      <a:solidFill>
+                        <a:schemeClr val="lt1">
+                          <a:alpha val="35000"/>
+                        </a:schemeClr>
+                      </a:solidFill>
+                      <a:prstDash val="solid"/>
+                    </a:lnB>
+                    <a:noFill/>
+                  </a:tcPr>
+                </a:tc>
+                <a:tc>
+                  <a:txBody>
+                    <a:bodyPr/>
+                    <a:lstStyle/>
+                    <a:p>
+                      <a:pPr marL="0" lvl="0" indent="0" algn="r" rtl="0">
+                        <a:buNone/>
+                      </a:pPr>
+                      <a:r>
+                        <a:rPr lang="en-GB" sz="1300" dirty="0">
+                          <a:solidFill>
+                            <a:schemeClr val="lt1"/>
+                          </a:solidFill>
+                        </a:rPr>
+                        <a:t>96.46%</a:t>
+                      </a:r>
+                      <a:endParaRPr sz="1300">
+                        <a:solidFill>
+                          <a:schemeClr val="lt1"/>
+                        </a:solidFill>
+                      </a:endParaRPr>
+                    </a:p>
+                  </a:txBody>
+                  <a:tcPr marL="91440" marR="91440" marT="45720" marB="45720" anchor="ctr">
+                    <a:lnB w="9525" cap="flat" cmpd="sng">
+                      <a:solidFill>
+                        <a:schemeClr val="lt1">
+                          <a:alpha val="35000"/>
+                        </a:schemeClr>
+                      </a:solidFill>
+                      <a:prstDash val="solid"/>
+                    </a:lnB>
+                    <a:noFill/>
+                  </a:tcPr>
+                </a:tc>
+                <a:tc>
+                  <a:txBody>
+                    <a:bodyPr/>
+                    <a:lstStyle/>
+                    <a:p>
+                      <a:pPr marL="0" lvl="0" indent="0" algn="r" rtl="0">
+                        <a:buNone/>
+                      </a:pPr>
+                      <a:r>
+                        <a:rPr lang="en-GB" sz="1300" dirty="0">
+                          <a:solidFill>
+                            <a:schemeClr val="lt1"/>
+                          </a:solidFill>
+                        </a:rPr>
+                        <a:t>0.963</a:t>
+                      </a:r>
+                      <a:endParaRPr sz="1300">
+                        <a:solidFill>
+                          <a:schemeClr val="lt1"/>
+                        </a:solidFill>
+                      </a:endParaRPr>
+                    </a:p>
+                  </a:txBody>
+                  <a:tcPr marL="91440" marR="91440" marT="45720" marB="45720" anchor="ctr">
+                    <a:lnB w="9525" cap="flat" cmpd="sng">
+                      <a:solidFill>
+                        <a:schemeClr val="lt1">
+                          <a:alpha val="35000"/>
+                        </a:schemeClr>
+                      </a:solidFill>
+                      <a:prstDash val="solid"/>
+                    </a:lnB>
+                    <a:noFill/>
+                  </a:tcPr>
+                </a:tc>
+              </a:tr>
+              <a:tr h="430000">
+                <a:tc>
+                  <a:txBody>
+                    <a:bodyPr/>
+                    <a:lstStyle/>
+                    <a:p>
+                      <a:pPr marL="0" lvl="0" indent="0" algn="l" rtl="0">
+                        <a:buNone/>
+                      </a:pPr>
+                      <a:r>
+                        <a:rPr lang="en-GB" sz="1300" dirty="0">
+                          <a:solidFill>
+                            <a:schemeClr val="lt1"/>
+                          </a:solidFill>
+                        </a:rPr>
+                        <a:t>BiLSTM (from scratch)</a:t>
+                      </a:r>
+                      <a:endParaRPr sz="1300">
+                        <a:solidFill>
+                          <a:schemeClr val="lt1"/>
+                        </a:solidFill>
+                      </a:endParaRPr>
+                    </a:p>
+                  </a:txBody>
+                  <a:tcPr marL="91440" marR="91440" marT="45720" marB="45720" anchor="ctr">
+                    <a:lnB w="9525" cap="flat" cmpd="sng">
+                      <a:solidFill>
+                        <a:schemeClr val="lt1">
+                          <a:alpha val="35000"/>
+                        </a:schemeClr>
+                      </a:solidFill>
+                      <a:prstDash val="solid"/>
+                    </a:lnB>
+                    <a:noFill/>
+                  </a:tcPr>
+                </a:tc>
+                <a:tc>
+                  <a:txBody>
+                    <a:bodyPr/>
+                    <a:lstStyle/>
+                    <a:p>
+                      <a:pPr marL="0" lvl="0" indent="0" algn="l" rtl="0">
+                        <a:buNone/>
+                      </a:pPr>
+                      <a:r>
+                        <a:rPr lang="en-GB" sz="1300" dirty="0">
+                          <a:solidFill>
+                            <a:schemeClr val="lt1"/>
+                          </a:solidFill>
+                        </a:rPr>
+                        <a:t>Deep Learning</a:t>
+                      </a:r>
+                      <a:endParaRPr sz="1300">
+                        <a:solidFill>
+                          <a:schemeClr val="lt1"/>
+                        </a:solidFill>
+                      </a:endParaRPr>
+                    </a:p>
+                  </a:txBody>
+                  <a:tcPr marL="91440" marR="91440" marT="45720" marB="45720" anchor="ctr">
+                    <a:lnB w="9525" cap="flat" cmpd="sng">
+                      <a:solidFill>
+                        <a:schemeClr val="lt1">
+                          <a:alpha val="35000"/>
+                        </a:schemeClr>
+                      </a:solidFill>
+                      <a:prstDash val="solid"/>
+                    </a:lnB>
+                    <a:noFill/>
+                  </a:tcPr>
+                </a:tc>
+                <a:tc>
+                  <a:txBody>
+                    <a:bodyPr/>
+                    <a:lstStyle/>
+                    <a:p>
+                      <a:pPr marL="0" lvl="0" indent="0" algn="r" rtl="0">
+                        <a:buNone/>
+                      </a:pPr>
+                      <a:r>
+                        <a:rPr lang="en-GB" sz="1300" dirty="0">
+                          <a:solidFill>
+                            <a:schemeClr val="lt1"/>
+                          </a:solidFill>
+                        </a:rPr>
+                        <a:t>81.55%</a:t>
+                      </a:r>
+                      <a:endParaRPr sz="1300">
+                        <a:solidFill>
+                          <a:schemeClr val="lt1"/>
+                        </a:solidFill>
+                      </a:endParaRPr>
+                    </a:p>
+                  </a:txBody>
+                  <a:tcPr marL="91440" marR="91440" marT="45720" marB="45720" anchor="ctr">
+                    <a:lnB w="9525" cap="flat" cmpd="sng">
+                      <a:solidFill>
+                        <a:schemeClr val="lt1">
+                          <a:alpha val="35000"/>
+                        </a:schemeClr>
+                      </a:solidFill>
+                      <a:prstDash val="solid"/>
+                    </a:lnB>
+                    <a:noFill/>
+                  </a:tcPr>
+                </a:tc>
+                <a:tc>
+                  <a:txBody>
+                    <a:bodyPr/>
+                    <a:lstStyle/>
+                    <a:p>
+                      <a:pPr marL="0" lvl="0" indent="0" algn="r" rtl="0">
+                        <a:buNone/>
+                      </a:pPr>
+                      <a:r>
+                        <a:rPr lang="en-GB" sz="1300" dirty="0">
+                          <a:solidFill>
+                            <a:schemeClr val="lt1"/>
+                          </a:solidFill>
+                        </a:rPr>
+                        <a:t>0.810</a:t>
+                      </a:r>
+                      <a:endParaRPr sz="1300">
+                        <a:solidFill>
+                          <a:schemeClr val="lt1"/>
+                        </a:solidFill>
+                      </a:endParaRPr>
+                    </a:p>
+                  </a:txBody>
+                  <a:tcPr marL="91440" marR="91440" marT="45720" marB="45720" anchor="ctr">
+                    <a:lnB w="9525" cap="flat" cmpd="sng">
+                      <a:solidFill>
+                        <a:schemeClr val="lt1">
+                          <a:alpha val="35000"/>
+                        </a:schemeClr>
+                      </a:solidFill>
+                      <a:prstDash val="solid"/>
+                    </a:lnB>
+                    <a:noFill/>
+                  </a:tcPr>
+                </a:tc>
+              </a:tr>
+            </a:tbl>
+          </a:graphicData>
+        </a:graphic>
+      </p:graphicFrame>
     </p:spTree>
   </p:cSld>
   <p:clrMapOvr>

</xml_diff>